<commit_message>
📝 docs: Task Master AI 설치 및 사용법 정리
</commit_message>
<xml_diff>
--- a/PPT정리/29. Task Master AI.pptx
+++ b/PPT정리/29. Task Master AI.pptx
@@ -10,6 +10,19 @@
     <p:sldId id="259" r:id="rId4"/>
     <p:sldId id="260" r:id="rId5"/>
     <p:sldId id="261" r:id="rId6"/>
+    <p:sldId id="262" r:id="rId7"/>
+    <p:sldId id="263" r:id="rId8"/>
+    <p:sldId id="264" r:id="rId9"/>
+    <p:sldId id="265" r:id="rId10"/>
+    <p:sldId id="266" r:id="rId11"/>
+    <p:sldId id="267" r:id="rId12"/>
+    <p:sldId id="268" r:id="rId13"/>
+    <p:sldId id="269" r:id="rId14"/>
+    <p:sldId id="270" r:id="rId15"/>
+    <p:sldId id="271" r:id="rId16"/>
+    <p:sldId id="272" r:id="rId17"/>
+    <p:sldId id="273" r:id="rId18"/>
+    <p:sldId id="275" r:id="rId19"/>
   </p:sldIdLst>
   <p:sldSz cx="12192000" cy="6858000"/>
   <p:notesSz cx="6858000" cy="9144000"/>
@@ -108,6 +121,45 @@
       </a:defRPr>
     </a:lvl9pPr>
   </p:defaultTextStyle>
+  <p:extLst>
+    <p:ext uri="{521415D9-36F7-43E2-AB2F-B90AF26B5E84}">
+      <p14:sectionLst xmlns:p14="http://schemas.microsoft.com/office/powerpoint/2010/main">
+        <p14:section name="기본 구역" id="{7AA4F872-6643-46D7-9DD7-D328219597E2}">
+          <p14:sldIdLst>
+            <p14:sldId id="256"/>
+            <p14:sldId id="258"/>
+            <p14:sldId id="259"/>
+            <p14:sldId id="260"/>
+            <p14:sldId id="261"/>
+            <p14:sldId id="262"/>
+            <p14:sldId id="263"/>
+            <p14:sldId id="264"/>
+          </p14:sldIdLst>
+        </p14:section>
+        <p14:section name="Task Manager 사용법" id="{BE2535E6-F2E5-4344-BB4D-B063043BBCA3}">
+          <p14:sldIdLst>
+            <p14:sldId id="265"/>
+            <p14:sldId id="266"/>
+            <p14:sldId id="267"/>
+            <p14:sldId id="268"/>
+            <p14:sldId id="269"/>
+            <p14:sldId id="270"/>
+            <p14:sldId id="271"/>
+            <p14:sldId id="272"/>
+            <p14:sldId id="273"/>
+          </p14:sldIdLst>
+        </p14:section>
+        <p14:section name="Work Flow" id="{3AD72D8F-F0E9-4975-BF44-264F88C77654}">
+          <p14:sldIdLst>
+            <p14:sldId id="275"/>
+          </p14:sldIdLst>
+        </p14:section>
+      </p14:sectionLst>
+    </p:ext>
+    <p:ext uri="{EFAFB233-063F-42B5-8137-9DF3F51BA10A}">
+      <p15:sldGuideLst xmlns:p15="http://schemas.microsoft.com/office/powerpoint/2012/main"/>
+    </p:ext>
+  </p:extLst>
 </p:presentation>
 </file>
 
@@ -337,7 +389,7 @@
           <a:p>
             <a:fld id="{FDCCB462-B40D-428D-8FC4-842D104849FE}" type="datetimeFigureOut">
               <a:rPr lang="ko-KR" altLang="en-US" smtClean="0"/>
-              <a:t>2026-07-01</a:t>
+              <a:t>2026-07-02</a:t>
             </a:fld>
             <a:endParaRPr lang="ko-KR" altLang="en-US"/>
           </a:p>
@@ -545,7 +597,7 @@
           <a:p>
             <a:fld id="{FDCCB462-B40D-428D-8FC4-842D104849FE}" type="datetimeFigureOut">
               <a:rPr lang="ko-KR" altLang="en-US" smtClean="0"/>
-              <a:t>2026-07-01</a:t>
+              <a:t>2026-07-02</a:t>
             </a:fld>
             <a:endParaRPr lang="ko-KR" altLang="en-US"/>
           </a:p>
@@ -801,7 +853,7 @@
           <a:p>
             <a:fld id="{FDCCB462-B40D-428D-8FC4-842D104849FE}" type="datetimeFigureOut">
               <a:rPr lang="ko-KR" altLang="en-US" smtClean="0"/>
-              <a:t>2026-07-01</a:t>
+              <a:t>2026-07-02</a:t>
             </a:fld>
             <a:endParaRPr lang="ko-KR" altLang="en-US"/>
           </a:p>
@@ -975,7 +1027,7 @@
           <a:p>
             <a:fld id="{FDCCB462-B40D-428D-8FC4-842D104849FE}" type="datetimeFigureOut">
               <a:rPr lang="ko-KR" altLang="en-US" smtClean="0"/>
-              <a:t>2026-07-01</a:t>
+              <a:t>2026-07-02</a:t>
             </a:fld>
             <a:endParaRPr lang="ko-KR" altLang="en-US"/>
           </a:p>
@@ -1318,7 +1370,7 @@
           <a:p>
             <a:fld id="{FDCCB462-B40D-428D-8FC4-842D104849FE}" type="datetimeFigureOut">
               <a:rPr lang="ko-KR" altLang="en-US" smtClean="0"/>
-              <a:t>2026-07-01</a:t>
+              <a:t>2026-07-02</a:t>
             </a:fld>
             <a:endParaRPr lang="ko-KR" altLang="en-US"/>
           </a:p>
@@ -1593,7 +1645,7 @@
           <a:p>
             <a:fld id="{FDCCB462-B40D-428D-8FC4-842D104849FE}" type="datetimeFigureOut">
               <a:rPr lang="ko-KR" altLang="en-US" smtClean="0"/>
-              <a:t>2026-07-01</a:t>
+              <a:t>2026-07-02</a:t>
             </a:fld>
             <a:endParaRPr lang="ko-KR" altLang="en-US"/>
           </a:p>
@@ -1972,7 +2024,7 @@
           <a:p>
             <a:fld id="{FDCCB462-B40D-428D-8FC4-842D104849FE}" type="datetimeFigureOut">
               <a:rPr lang="ko-KR" altLang="en-US" smtClean="0"/>
-              <a:t>2026-07-01</a:t>
+              <a:t>2026-07-02</a:t>
             </a:fld>
             <a:endParaRPr lang="ko-KR" altLang="en-US"/>
           </a:p>
@@ -2090,7 +2142,7 @@
           <a:p>
             <a:fld id="{FDCCB462-B40D-428D-8FC4-842D104849FE}" type="datetimeFigureOut">
               <a:rPr lang="ko-KR" altLang="en-US" smtClean="0"/>
-              <a:t>2026-07-01</a:t>
+              <a:t>2026-07-02</a:t>
             </a:fld>
             <a:endParaRPr lang="ko-KR" altLang="en-US"/>
           </a:p>
@@ -2261,7 +2313,7 @@
           <a:p>
             <a:fld id="{FDCCB462-B40D-428D-8FC4-842D104849FE}" type="datetimeFigureOut">
               <a:rPr lang="ko-KR" altLang="en-US" smtClean="0"/>
-              <a:t>2026-07-01</a:t>
+              <a:t>2026-07-02</a:t>
             </a:fld>
             <a:endParaRPr lang="ko-KR" altLang="en-US"/>
           </a:p>
@@ -2615,7 +2667,7 @@
           <a:p>
             <a:fld id="{FDCCB462-B40D-428D-8FC4-842D104849FE}" type="datetimeFigureOut">
               <a:rPr lang="ko-KR" altLang="en-US" smtClean="0"/>
-              <a:t>2026-07-01</a:t>
+              <a:t>2026-07-02</a:t>
             </a:fld>
             <a:endParaRPr lang="ko-KR" altLang="en-US"/>
           </a:p>
@@ -2899,7 +2951,7 @@
               <a:rPr lang="ko-KR" altLang="en-US"/>
               <a:t>그림을 추가하려면 아이콘을 클릭하십시오</a:t>
             </a:r>
-            <a:endParaRPr lang="en-US" dirty="0"/>
+            <a:endParaRPr lang="en-US"/>
           </a:p>
         </p:txBody>
       </p:sp>
@@ -2997,7 +3049,7 @@
           <a:p>
             <a:fld id="{FDCCB462-B40D-428D-8FC4-842D104849FE}" type="datetimeFigureOut">
               <a:rPr lang="ko-KR" altLang="en-US" smtClean="0"/>
-              <a:t>2026-07-01</a:t>
+              <a:t>2026-07-02</a:t>
             </a:fld>
             <a:endParaRPr lang="ko-KR" altLang="en-US"/>
           </a:p>
@@ -3284,7 +3336,7 @@
           <a:p>
             <a:fld id="{FDCCB462-B40D-428D-8FC4-842D104849FE}" type="datetimeFigureOut">
               <a:rPr lang="ko-KR" altLang="en-US" smtClean="0"/>
-              <a:t>2026-07-01</a:t>
+              <a:t>2026-07-02</a:t>
             </a:fld>
             <a:endParaRPr lang="ko-KR" altLang="en-US"/>
           </a:p>
@@ -3830,10 +3882,10 @@
           <a:lstStyle/>
           <a:p>
             <a:r>
-              <a:rPr lang="en-US" altLang="ko-KR" dirty="0"/>
+              <a:rPr lang="en-US" altLang="ko-KR"/>
               <a:t>Task Master AI</a:t>
             </a:r>
-            <a:endParaRPr lang="ko-KR" altLang="en-US" dirty="0"/>
+            <a:endParaRPr lang="ko-KR" altLang="en-US"/>
           </a:p>
         </p:txBody>
       </p:sp>
@@ -3866,6 +3918,2554 @@
     <p:extLst>
       <p:ext uri="{BB962C8B-B14F-4D97-AF65-F5344CB8AC3E}">
         <p14:creationId xmlns:p14="http://schemas.microsoft.com/office/powerpoint/2010/main" val="1811025580"/>
+      </p:ext>
+    </p:extLst>
+  </p:cSld>
+  <p:clrMapOvr>
+    <a:masterClrMapping/>
+  </p:clrMapOvr>
+</p:sld>
+</file>
+
+<file path=ppt/slides/slide10.xml><?xml version="1.0" encoding="utf-8"?>
+<p:sld xmlns:a="http://schemas.openxmlformats.org/drawingml/2006/main" xmlns:r="http://schemas.openxmlformats.org/officeDocument/2006/relationships" xmlns:p="http://schemas.openxmlformats.org/presentationml/2006/main">
+  <p:cSld>
+    <p:spTree>
+      <p:nvGrpSpPr>
+        <p:cNvPr id="1" name=""/>
+        <p:cNvGrpSpPr/>
+        <p:nvPr/>
+      </p:nvGrpSpPr>
+      <p:grpSpPr>
+        <a:xfrm>
+          <a:off x="0" y="0"/>
+          <a:ext cx="0" cy="0"/>
+          <a:chOff x="0" y="0"/>
+          <a:chExt cx="0" cy="0"/>
+        </a:xfrm>
+      </p:grpSpPr>
+      <p:sp>
+        <p:nvSpPr>
+          <p:cNvPr id="2" name="제목 1">
+            <a:extLst>
+              <a:ext uri="{FF2B5EF4-FFF2-40B4-BE49-F238E27FC236}">
+                <a16:creationId xmlns:a16="http://schemas.microsoft.com/office/drawing/2014/main" id="{FD157926-BB7E-D7A2-598D-6D8525112841}"/>
+              </a:ext>
+            </a:extLst>
+          </p:cNvPr>
+          <p:cNvSpPr>
+            <a:spLocks noGrp="1"/>
+          </p:cNvSpPr>
+          <p:nvPr>
+            <p:ph type="title"/>
+          </p:nvPr>
+        </p:nvSpPr>
+        <p:spPr/>
+        <p:txBody>
+          <a:bodyPr/>
+          <a:lstStyle/>
+          <a:p>
+            <a:r>
+              <a:rPr lang="ko-KR" altLang="en-US"/>
+              <a:t>현재 셋팅 모델 확인 및 변경</a:t>
+            </a:r>
+          </a:p>
+        </p:txBody>
+      </p:sp>
+      <p:pic>
+        <p:nvPicPr>
+          <p:cNvPr id="4" name="그림 3">
+            <a:extLst>
+              <a:ext uri="{FF2B5EF4-FFF2-40B4-BE49-F238E27FC236}">
+                <a16:creationId xmlns:a16="http://schemas.microsoft.com/office/drawing/2014/main" id="{AB45FFD4-EB79-6E67-F34D-B46B4A9ACB46}"/>
+              </a:ext>
+            </a:extLst>
+          </p:cNvPr>
+          <p:cNvPicPr>
+            <a:picLocks noChangeAspect="1"/>
+          </p:cNvPicPr>
+          <p:nvPr/>
+        </p:nvPicPr>
+        <p:blipFill>
+          <a:blip r:embed="rId2"/>
+          <a:stretch>
+            <a:fillRect/>
+          </a:stretch>
+        </p:blipFill>
+        <p:spPr>
+          <a:xfrm>
+            <a:off x="365316" y="1904785"/>
+            <a:ext cx="9721365" cy="3048429"/>
+          </a:xfrm>
+          <a:prstGeom prst="rect">
+            <a:avLst/>
+          </a:prstGeom>
+        </p:spPr>
+      </p:pic>
+      <p:sp>
+        <p:nvSpPr>
+          <p:cNvPr id="5" name="TextBox 4">
+            <a:extLst>
+              <a:ext uri="{FF2B5EF4-FFF2-40B4-BE49-F238E27FC236}">
+                <a16:creationId xmlns:a16="http://schemas.microsoft.com/office/drawing/2014/main" id="{E6346CC1-926A-9DD9-C1A4-7EC977D142F2}"/>
+              </a:ext>
+            </a:extLst>
+          </p:cNvPr>
+          <p:cNvSpPr txBox="1"/>
+          <p:nvPr/>
+        </p:nvSpPr>
+        <p:spPr>
+          <a:xfrm>
+            <a:off x="365316" y="5071621"/>
+            <a:ext cx="9721365" cy="738664"/>
+          </a:xfrm>
+          <a:prstGeom prst="rect">
+            <a:avLst/>
+          </a:prstGeom>
+          <a:noFill/>
+        </p:spPr>
+        <p:txBody>
+          <a:bodyPr wrap="square" rtlCol="0">
+            <a:spAutoFit/>
+          </a:bodyPr>
+          <a:lstStyle/>
+          <a:p>
+            <a:r>
+              <a:rPr lang="ko-KR" altLang="en-US" sz="1400"/>
+              <a:t>변경 명령 </a:t>
+            </a:r>
+            <a:br>
+              <a:rPr lang="en-US" altLang="ko-KR" sz="1400"/>
+            </a:br>
+            <a:r>
+              <a:rPr lang="en-US" altLang="ko-KR" sz="1400">
+                <a:solidFill>
+                  <a:srgbClr val="FF0000"/>
+                </a:solidFill>
+              </a:rPr>
+              <a:t>@.taskmaster </a:t>
+            </a:r>
+            <a:r>
+              <a:rPr lang="en-US" altLang="ko-KR" sz="1400">
+                <a:solidFill>
+                  <a:srgbClr val="0000FF"/>
+                </a:solidFill>
+              </a:rPr>
+              <a:t>tm  models --setup </a:t>
+            </a:r>
+          </a:p>
+          <a:p>
+            <a:endParaRPr lang="ko-KR" altLang="en-US" sz="1400"/>
+          </a:p>
+        </p:txBody>
+      </p:sp>
+    </p:spTree>
+    <p:extLst>
+      <p:ext uri="{BB962C8B-B14F-4D97-AF65-F5344CB8AC3E}">
+        <p14:creationId xmlns:p14="http://schemas.microsoft.com/office/powerpoint/2010/main" val="880087958"/>
+      </p:ext>
+    </p:extLst>
+  </p:cSld>
+  <p:clrMapOvr>
+    <a:masterClrMapping/>
+  </p:clrMapOvr>
+</p:sld>
+</file>
+
+<file path=ppt/slides/slide11.xml><?xml version="1.0" encoding="utf-8"?>
+<p:sld xmlns:a="http://schemas.openxmlformats.org/drawingml/2006/main" xmlns:r="http://schemas.openxmlformats.org/officeDocument/2006/relationships" xmlns:p="http://schemas.openxmlformats.org/presentationml/2006/main">
+  <p:cSld>
+    <p:spTree>
+      <p:nvGrpSpPr>
+        <p:cNvPr id="1" name=""/>
+        <p:cNvGrpSpPr/>
+        <p:nvPr/>
+      </p:nvGrpSpPr>
+      <p:grpSpPr>
+        <a:xfrm>
+          <a:off x="0" y="0"/>
+          <a:ext cx="0" cy="0"/>
+          <a:chOff x="0" y="0"/>
+          <a:chExt cx="0" cy="0"/>
+        </a:xfrm>
+      </p:grpSpPr>
+      <p:sp>
+        <p:nvSpPr>
+          <p:cNvPr id="2" name="제목 1">
+            <a:extLst>
+              <a:ext uri="{FF2B5EF4-FFF2-40B4-BE49-F238E27FC236}">
+                <a16:creationId xmlns:a16="http://schemas.microsoft.com/office/drawing/2014/main" id="{9BA50DD3-A7DF-7178-A550-9E9BFA5190A9}"/>
+              </a:ext>
+            </a:extLst>
+          </p:cNvPr>
+          <p:cNvSpPr>
+            <a:spLocks noGrp="1"/>
+          </p:cNvSpPr>
+          <p:nvPr>
+            <p:ph type="title"/>
+          </p:nvPr>
+        </p:nvSpPr>
+        <p:spPr/>
+        <p:txBody>
+          <a:bodyPr>
+            <a:normAutofit/>
+          </a:bodyPr>
+          <a:lstStyle/>
+          <a:p>
+            <a:r>
+              <a:rPr lang="en-US" altLang="ko-KR" sz="3600"/>
+              <a:t>Shrimp Task Master </a:t>
+            </a:r>
+            <a:r>
+              <a:rPr lang="ko-KR" altLang="en-US" sz="3600"/>
+              <a:t>와 </a:t>
+            </a:r>
+            <a:r>
+              <a:rPr lang="en-US" altLang="ko-KR" sz="3600"/>
+              <a:t>Task Master - </a:t>
+            </a:r>
+            <a:r>
+              <a:rPr lang="ko-KR" altLang="en-US" sz="3600"/>
+              <a:t>특징</a:t>
+            </a:r>
+          </a:p>
+        </p:txBody>
+      </p:sp>
+      <p:sp>
+        <p:nvSpPr>
+          <p:cNvPr id="3" name="TextBox 2">
+            <a:extLst>
+              <a:ext uri="{FF2B5EF4-FFF2-40B4-BE49-F238E27FC236}">
+                <a16:creationId xmlns:a16="http://schemas.microsoft.com/office/drawing/2014/main" id="{73A71CB9-7172-463E-1B51-944D8D33B540}"/>
+              </a:ext>
+            </a:extLst>
+          </p:cNvPr>
+          <p:cNvSpPr txBox="1"/>
+          <p:nvPr/>
+        </p:nvSpPr>
+        <p:spPr>
+          <a:xfrm>
+            <a:off x="1197204" y="1838227"/>
+            <a:ext cx="9958476" cy="3416320"/>
+          </a:xfrm>
+          <a:prstGeom prst="rect">
+            <a:avLst/>
+          </a:prstGeom>
+          <a:noFill/>
+        </p:spPr>
+        <p:txBody>
+          <a:bodyPr wrap="square" rtlCol="0">
+            <a:spAutoFit/>
+          </a:bodyPr>
+          <a:lstStyle/>
+          <a:p>
+            <a:r>
+              <a:rPr lang="en-US" altLang="ko-KR" sz="1200"/>
+              <a:t>Shrimp – master </a:t>
+            </a:r>
+            <a:r>
+              <a:rPr lang="ko-KR" altLang="en-US" sz="1200"/>
+              <a:t>는 작성하려는 웹의 특징과 기능</a:t>
+            </a:r>
+            <a:r>
+              <a:rPr lang="en-US" altLang="ko-KR" sz="1200"/>
+              <a:t>,</a:t>
+            </a:r>
+            <a:r>
+              <a:rPr lang="ko-KR" altLang="en-US" sz="1200"/>
+              <a:t> 기술스택을 제시하고 그에 맞는 프로젝트 룰과 절차에 대한 </a:t>
+            </a:r>
+            <a:r>
+              <a:rPr lang="en-US" altLang="ko-KR" sz="1200"/>
+              <a:t>PRD </a:t>
+            </a:r>
+            <a:r>
+              <a:rPr lang="ko-KR" altLang="en-US" sz="1200"/>
+              <a:t>문서를 작성해달라고 하면</a:t>
+            </a:r>
+            <a:br>
+              <a:rPr lang="en-US" altLang="ko-KR" sz="1200"/>
+            </a:br>
+            <a:r>
+              <a:rPr lang="en-US" altLang="ko-KR" sz="1200"/>
+              <a:t>AI</a:t>
+            </a:r>
+            <a:r>
+              <a:rPr lang="ko-KR" altLang="en-US" sz="1200"/>
+              <a:t>의 기준으로 잘 생성해주며</a:t>
+            </a:r>
+            <a:r>
+              <a:rPr lang="en-US" altLang="ko-KR" sz="1200"/>
+              <a:t>, </a:t>
+            </a:r>
+            <a:r>
+              <a:rPr lang="ko-KR" altLang="en-US" sz="1200"/>
+              <a:t>이에 따른 작업과 계획을 관리한다</a:t>
+            </a:r>
+            <a:r>
+              <a:rPr lang="en-US" altLang="ko-KR" sz="1200"/>
+              <a:t>.</a:t>
+            </a:r>
+          </a:p>
+          <a:p>
+            <a:br>
+              <a:rPr lang="en-US" altLang="ko-KR" sz="1200"/>
+            </a:br>
+            <a:r>
+              <a:rPr lang="ko-KR" altLang="en-US" sz="1200"/>
+              <a:t>그러나 </a:t>
+            </a:r>
+            <a:r>
+              <a:rPr lang="en-US" altLang="ko-KR" sz="1200"/>
+              <a:t>Claude Taskmaster </a:t>
+            </a:r>
+            <a:r>
+              <a:rPr lang="ko-KR" altLang="en-US" sz="1200"/>
+              <a:t>의 경우는 절차적으로 이미 잘 계획된</a:t>
+            </a:r>
+            <a:r>
+              <a:rPr lang="en-US" altLang="ko-KR" sz="1200"/>
+              <a:t>, PRD</a:t>
+            </a:r>
+            <a:r>
+              <a:rPr lang="ko-KR" altLang="en-US" sz="1200"/>
+              <a:t>를 기준으로 </a:t>
+            </a:r>
+            <a:r>
+              <a:rPr lang="en-US" altLang="ko-KR" sz="1200"/>
+              <a:t>Task</a:t>
+            </a:r>
+            <a:r>
+              <a:rPr lang="ko-KR" altLang="en-US" sz="1200"/>
+              <a:t>관리에 최적화된 도구이다</a:t>
+            </a:r>
+            <a:r>
+              <a:rPr lang="en-US" altLang="ko-KR" sz="1200"/>
+              <a:t>.</a:t>
+            </a:r>
+          </a:p>
+          <a:p>
+            <a:endParaRPr lang="en-US" altLang="ko-KR" sz="1200"/>
+          </a:p>
+          <a:p>
+            <a:r>
+              <a:rPr lang="ko-KR" altLang="en-US" sz="1200"/>
+              <a:t>두 </a:t>
+            </a:r>
+            <a:r>
+              <a:rPr lang="en-US" altLang="ko-KR" sz="1200"/>
+              <a:t>Task Master</a:t>
+            </a:r>
+            <a:r>
+              <a:rPr lang="ko-KR" altLang="en-US" sz="1200"/>
+              <a:t>의 경우에는 개발자의 현재 성향에 따라 사용하는데 서로다른 이점을 가질수 있다</a:t>
+            </a:r>
+            <a:r>
+              <a:rPr lang="en-US" altLang="ko-KR" sz="1200"/>
+              <a:t>.</a:t>
+            </a:r>
+          </a:p>
+          <a:p>
+            <a:endParaRPr lang="en-US" altLang="ko-KR" sz="1200"/>
+          </a:p>
+          <a:p>
+            <a:r>
+              <a:rPr lang="en-US" altLang="ko-KR" sz="1200"/>
+              <a:t>Shrimp Task Master</a:t>
+            </a:r>
+          </a:p>
+          <a:p>
+            <a:pPr marL="228600" indent="-228600">
+              <a:buAutoNum type="arabicPeriod"/>
+            </a:pPr>
+            <a:r>
+              <a:rPr lang="ko-KR" altLang="en-US" sz="1200">
+                <a:sym typeface="Wingdings" panose="05000000000000000000" pitchFamily="2" charset="2"/>
+              </a:rPr>
+              <a:t>시니어 개발자</a:t>
+            </a:r>
+            <a:endParaRPr lang="en-US" altLang="ko-KR" sz="1200">
+              <a:sym typeface="Wingdings" panose="05000000000000000000" pitchFamily="2" charset="2"/>
+            </a:endParaRPr>
+          </a:p>
+          <a:p>
+            <a:pPr marL="228600" indent="-228600">
+              <a:buAutoNum type="arabicPeriod"/>
+            </a:pPr>
+            <a:r>
+              <a:rPr lang="en-US" altLang="ko-KR" sz="1200">
+                <a:sym typeface="Wingdings" panose="05000000000000000000" pitchFamily="2" charset="2"/>
+              </a:rPr>
+              <a:t>PRD</a:t>
+            </a:r>
+            <a:r>
+              <a:rPr lang="ko-KR" altLang="en-US" sz="1200">
+                <a:sym typeface="Wingdings" panose="05000000000000000000" pitchFamily="2" charset="2"/>
+              </a:rPr>
+              <a:t> 가 완성 되어있지 않거나 모호한 경우</a:t>
+            </a:r>
+            <a:endParaRPr lang="en-US" altLang="ko-KR" sz="1200">
+              <a:sym typeface="Wingdings" panose="05000000000000000000" pitchFamily="2" charset="2"/>
+            </a:endParaRPr>
+          </a:p>
+          <a:p>
+            <a:pPr marL="228600" indent="-228600">
+              <a:buAutoNum type="arabicPeriod"/>
+            </a:pPr>
+            <a:r>
+              <a:rPr lang="ko-KR" altLang="en-US" sz="1200">
+                <a:sym typeface="Wingdings" panose="05000000000000000000" pitchFamily="2" charset="2"/>
+              </a:rPr>
+              <a:t>프로젝트 기능별로 유연하게 구현을 하고 싶을때</a:t>
+            </a:r>
+            <a:endParaRPr lang="en-US" altLang="ko-KR" sz="1200">
+              <a:sym typeface="Wingdings" panose="05000000000000000000" pitchFamily="2" charset="2"/>
+            </a:endParaRPr>
+          </a:p>
+          <a:p>
+            <a:pPr marL="228600" indent="-228600">
+              <a:buAutoNum type="arabicPeriod"/>
+            </a:pPr>
+            <a:r>
+              <a:rPr lang="ko-KR" altLang="en-US" sz="1200"/>
+              <a:t>팀과의 소통과 절차적 개발보다 빠르게 </a:t>
+            </a:r>
+            <a:r>
+              <a:rPr lang="en-US" altLang="ko-KR" sz="1200"/>
+              <a:t>MVP </a:t>
+            </a:r>
+            <a:r>
+              <a:rPr lang="ko-KR" altLang="en-US" sz="1200"/>
+              <a:t>를 개발을 서둘러야하는 경우</a:t>
+            </a:r>
+            <a:endParaRPr lang="en-US" altLang="ko-KR" sz="1200"/>
+          </a:p>
+          <a:p>
+            <a:endParaRPr lang="en-US" altLang="ko-KR" sz="1200"/>
+          </a:p>
+          <a:p>
+            <a:r>
+              <a:rPr lang="en-US" altLang="ko-KR" sz="1200"/>
+              <a:t>Task Master</a:t>
+            </a:r>
+          </a:p>
+          <a:p>
+            <a:pPr marL="228600" indent="-228600">
+              <a:buAutoNum type="arabicPeriod"/>
+            </a:pPr>
+            <a:r>
+              <a:rPr lang="ko-KR" altLang="en-US" sz="1200"/>
+              <a:t>주니어</a:t>
+            </a:r>
+            <a:r>
+              <a:rPr lang="en-US" altLang="ko-KR" sz="1200"/>
+              <a:t> </a:t>
+            </a:r>
+            <a:r>
+              <a:rPr lang="ko-KR" altLang="en-US" sz="1200"/>
+              <a:t>및 프로 개발자</a:t>
+            </a:r>
+            <a:r>
+              <a:rPr lang="en-US" altLang="ko-KR" sz="1200"/>
+              <a:t>.</a:t>
+            </a:r>
+          </a:p>
+          <a:p>
+            <a:pPr marL="228600" indent="-228600">
+              <a:buAutoNum type="arabicPeriod"/>
+            </a:pPr>
+            <a:r>
+              <a:rPr lang="en-US" altLang="ko-KR" sz="1200"/>
+              <a:t>PRD</a:t>
+            </a:r>
+            <a:r>
+              <a:rPr lang="ko-KR" altLang="en-US" sz="1200"/>
+              <a:t> 가 절차적으로 그리고 체계적으로 갖추어진 경우</a:t>
+            </a:r>
+            <a:r>
+              <a:rPr lang="en-US" altLang="ko-KR" sz="1200"/>
+              <a:t>.</a:t>
+            </a:r>
+          </a:p>
+          <a:p>
+            <a:pPr marL="228600" indent="-228600">
+              <a:buAutoNum type="arabicPeriod"/>
+            </a:pPr>
+            <a:r>
+              <a:rPr lang="ko-KR" altLang="en-US" sz="1200"/>
+              <a:t>팀과의 소통 그리고 프로그램 기능이 순차적으로 작업되어야 하는 경우</a:t>
+            </a:r>
+            <a:r>
+              <a:rPr lang="en-US" altLang="ko-KR" sz="1200"/>
+              <a:t>.</a:t>
+            </a:r>
+            <a:br>
+              <a:rPr lang="en-US" altLang="ko-KR" sz="1200"/>
+            </a:br>
+            <a:endParaRPr lang="ko-KR" altLang="en-US" sz="1200"/>
+          </a:p>
+        </p:txBody>
+      </p:sp>
+    </p:spTree>
+    <p:extLst>
+      <p:ext uri="{BB962C8B-B14F-4D97-AF65-F5344CB8AC3E}">
+        <p14:creationId xmlns:p14="http://schemas.microsoft.com/office/powerpoint/2010/main" val="1743273415"/>
+      </p:ext>
+    </p:extLst>
+  </p:cSld>
+  <p:clrMapOvr>
+    <a:masterClrMapping/>
+  </p:clrMapOvr>
+</p:sld>
+</file>
+
+<file path=ppt/slides/slide12.xml><?xml version="1.0" encoding="utf-8"?>
+<p:sld xmlns:a="http://schemas.openxmlformats.org/drawingml/2006/main" xmlns:r="http://schemas.openxmlformats.org/officeDocument/2006/relationships" xmlns:p="http://schemas.openxmlformats.org/presentationml/2006/main">
+  <p:cSld>
+    <p:spTree>
+      <p:nvGrpSpPr>
+        <p:cNvPr id="1" name=""/>
+        <p:cNvGrpSpPr/>
+        <p:nvPr/>
+      </p:nvGrpSpPr>
+      <p:grpSpPr>
+        <a:xfrm>
+          <a:off x="0" y="0"/>
+          <a:ext cx="0" cy="0"/>
+          <a:chOff x="0" y="0"/>
+          <a:chExt cx="0" cy="0"/>
+        </a:xfrm>
+      </p:grpSpPr>
+      <p:sp>
+        <p:nvSpPr>
+          <p:cNvPr id="2" name="제목 1">
+            <a:extLst>
+              <a:ext uri="{FF2B5EF4-FFF2-40B4-BE49-F238E27FC236}">
+                <a16:creationId xmlns:a16="http://schemas.microsoft.com/office/drawing/2014/main" id="{C9714F96-15EE-99BF-EFEA-7CFC34B6F5FB}"/>
+              </a:ext>
+            </a:extLst>
+          </p:cNvPr>
+          <p:cNvSpPr>
+            <a:spLocks noGrp="1"/>
+          </p:cNvSpPr>
+          <p:nvPr>
+            <p:ph type="title"/>
+          </p:nvPr>
+        </p:nvSpPr>
+        <p:spPr/>
+        <p:txBody>
+          <a:bodyPr/>
+          <a:lstStyle/>
+          <a:p>
+            <a:r>
+              <a:rPr lang="en-US" altLang="ko-KR"/>
+              <a:t>Task Master </a:t>
+            </a:r>
+            <a:r>
+              <a:rPr lang="ko-KR" altLang="en-US"/>
+              <a:t>초기화 명령</a:t>
+            </a:r>
+          </a:p>
+        </p:txBody>
+      </p:sp>
+      <p:sp>
+        <p:nvSpPr>
+          <p:cNvPr id="3" name="TextBox 2">
+            <a:extLst>
+              <a:ext uri="{FF2B5EF4-FFF2-40B4-BE49-F238E27FC236}">
+                <a16:creationId xmlns:a16="http://schemas.microsoft.com/office/drawing/2014/main" id="{AAC24609-2A37-E9A1-F86B-73F1C371F69F}"/>
+              </a:ext>
+            </a:extLst>
+          </p:cNvPr>
+          <p:cNvSpPr txBox="1"/>
+          <p:nvPr/>
+        </p:nvSpPr>
+        <p:spPr>
+          <a:xfrm>
+            <a:off x="1178351" y="1894788"/>
+            <a:ext cx="10218655" cy="369332"/>
+          </a:xfrm>
+          <a:prstGeom prst="rect">
+            <a:avLst/>
+          </a:prstGeom>
+          <a:noFill/>
+        </p:spPr>
+        <p:txBody>
+          <a:bodyPr wrap="square" rtlCol="0">
+            <a:spAutoFit/>
+          </a:bodyPr>
+          <a:lstStyle/>
+          <a:p>
+            <a:r>
+              <a:rPr lang="en-US" altLang="ko-KR">
+                <a:solidFill>
+                  <a:srgbClr val="FF0000"/>
+                </a:solidFill>
+              </a:rPr>
+              <a:t>@.taskmaster </a:t>
+            </a:r>
+            <a:r>
+              <a:rPr lang="en-US" altLang="ko-KR">
+                <a:solidFill>
+                  <a:srgbClr val="0000FF"/>
+                </a:solidFill>
+              </a:rPr>
+              <a:t>tm init </a:t>
+            </a:r>
+            <a:r>
+              <a:rPr lang="en-US" altLang="ko-KR">
+                <a:sym typeface="Wingdings" panose="05000000000000000000" pitchFamily="2" charset="2"/>
+              </a:rPr>
+              <a:t> .taskmaster</a:t>
+            </a:r>
+            <a:r>
+              <a:rPr lang="ko-KR" altLang="en-US">
+                <a:sym typeface="Wingdings" panose="05000000000000000000" pitchFamily="2" charset="2"/>
+              </a:rPr>
+              <a:t> 디렉터리 구조의 뼈대를 만듬</a:t>
+            </a:r>
+            <a:r>
+              <a:rPr lang="en-US" altLang="ko-KR">
+                <a:sym typeface="Wingdings" panose="05000000000000000000" pitchFamily="2" charset="2"/>
+              </a:rPr>
+              <a:t>.</a:t>
+            </a:r>
+            <a:endParaRPr lang="ko-KR" altLang="en-US"/>
+          </a:p>
+        </p:txBody>
+      </p:sp>
+    </p:spTree>
+    <p:extLst>
+      <p:ext uri="{BB962C8B-B14F-4D97-AF65-F5344CB8AC3E}">
+        <p14:creationId xmlns:p14="http://schemas.microsoft.com/office/powerpoint/2010/main" val="3722403150"/>
+      </p:ext>
+    </p:extLst>
+  </p:cSld>
+  <p:clrMapOvr>
+    <a:masterClrMapping/>
+  </p:clrMapOvr>
+</p:sld>
+</file>
+
+<file path=ppt/slides/slide13.xml><?xml version="1.0" encoding="utf-8"?>
+<p:sld xmlns:a="http://schemas.openxmlformats.org/drawingml/2006/main" xmlns:r="http://schemas.openxmlformats.org/officeDocument/2006/relationships" xmlns:p="http://schemas.openxmlformats.org/presentationml/2006/main">
+  <p:cSld>
+    <p:spTree>
+      <p:nvGrpSpPr>
+        <p:cNvPr id="1" name=""/>
+        <p:cNvGrpSpPr/>
+        <p:nvPr/>
+      </p:nvGrpSpPr>
+      <p:grpSpPr>
+        <a:xfrm>
+          <a:off x="0" y="0"/>
+          <a:ext cx="0" cy="0"/>
+          <a:chOff x="0" y="0"/>
+          <a:chExt cx="0" cy="0"/>
+        </a:xfrm>
+      </p:grpSpPr>
+      <p:sp>
+        <p:nvSpPr>
+          <p:cNvPr id="2" name="제목 1">
+            <a:extLst>
+              <a:ext uri="{FF2B5EF4-FFF2-40B4-BE49-F238E27FC236}">
+                <a16:creationId xmlns:a16="http://schemas.microsoft.com/office/drawing/2014/main" id="{5471A08C-2DE2-3FE9-ED61-2646197F77B0}"/>
+              </a:ext>
+            </a:extLst>
+          </p:cNvPr>
+          <p:cNvSpPr>
+            <a:spLocks noGrp="1"/>
+          </p:cNvSpPr>
+          <p:nvPr>
+            <p:ph type="title"/>
+          </p:nvPr>
+        </p:nvSpPr>
+        <p:spPr/>
+        <p:txBody>
+          <a:bodyPr/>
+          <a:lstStyle/>
+          <a:p>
+            <a:r>
+              <a:rPr lang="en-US" altLang="ko-KR"/>
+              <a:t>Task Master PRD</a:t>
+            </a:r>
+            <a:r>
+              <a:rPr lang="ko-KR" altLang="en-US"/>
+              <a:t> 생성</a:t>
+            </a:r>
+            <a:r>
+              <a:rPr lang="en-US" altLang="ko-KR"/>
+              <a:t>.</a:t>
+            </a:r>
+            <a:endParaRPr lang="ko-KR" altLang="en-US"/>
+          </a:p>
+        </p:txBody>
+      </p:sp>
+      <p:pic>
+        <p:nvPicPr>
+          <p:cNvPr id="6" name="그림 5">
+            <a:extLst>
+              <a:ext uri="{FF2B5EF4-FFF2-40B4-BE49-F238E27FC236}">
+                <a16:creationId xmlns:a16="http://schemas.microsoft.com/office/drawing/2014/main" id="{9442E57B-30F7-8F38-21B9-79CCFEF0985C}"/>
+              </a:ext>
+            </a:extLst>
+          </p:cNvPr>
+          <p:cNvPicPr>
+            <a:picLocks noChangeAspect="1"/>
+          </p:cNvPicPr>
+          <p:nvPr/>
+        </p:nvPicPr>
+        <p:blipFill>
+          <a:blip r:embed="rId2"/>
+          <a:stretch>
+            <a:fillRect/>
+          </a:stretch>
+        </p:blipFill>
+        <p:spPr>
+          <a:xfrm>
+            <a:off x="357750" y="1894788"/>
+            <a:ext cx="4827750" cy="4375148"/>
+          </a:xfrm>
+          <a:prstGeom prst="rect">
+            <a:avLst/>
+          </a:prstGeom>
+          <a:ln>
+            <a:solidFill>
+              <a:schemeClr val="tx1"/>
+            </a:solidFill>
+          </a:ln>
+        </p:spPr>
+      </p:pic>
+      <p:sp>
+        <p:nvSpPr>
+          <p:cNvPr id="7" name="TextBox 6">
+            <a:extLst>
+              <a:ext uri="{FF2B5EF4-FFF2-40B4-BE49-F238E27FC236}">
+                <a16:creationId xmlns:a16="http://schemas.microsoft.com/office/drawing/2014/main" id="{0801DEA8-F4C2-F7F4-4FE4-2E77B0B49D20}"/>
+              </a:ext>
+            </a:extLst>
+          </p:cNvPr>
+          <p:cNvSpPr txBox="1"/>
+          <p:nvPr/>
+        </p:nvSpPr>
+        <p:spPr>
+          <a:xfrm>
+            <a:off x="5279010" y="1894788"/>
+            <a:ext cx="6555240" cy="523220"/>
+          </a:xfrm>
+          <a:prstGeom prst="rect">
+            <a:avLst/>
+          </a:prstGeom>
+          <a:noFill/>
+        </p:spPr>
+        <p:txBody>
+          <a:bodyPr wrap="square" rtlCol="0">
+            <a:spAutoFit/>
+          </a:bodyPr>
+          <a:lstStyle/>
+          <a:p>
+            <a:r>
+              <a:rPr lang="en-US" altLang="ko-KR" sz="1400"/>
+              <a:t>※ Shrimp Task Master</a:t>
+            </a:r>
+            <a:r>
+              <a:rPr lang="ko-KR" altLang="en-US" sz="1400"/>
+              <a:t>는 </a:t>
+            </a:r>
+            <a:r>
+              <a:rPr lang="en-US" altLang="ko-KR" sz="1400"/>
+              <a:t>PRD </a:t>
+            </a:r>
+            <a:r>
+              <a:rPr lang="ko-KR" altLang="en-US" sz="1400"/>
+              <a:t>문서까지 만들어주지만 </a:t>
+            </a:r>
+            <a:r>
+              <a:rPr lang="en-US" altLang="ko-KR" sz="1400"/>
+              <a:t>Task Master</a:t>
+            </a:r>
+            <a:r>
+              <a:rPr lang="ko-KR" altLang="en-US" sz="1400"/>
+              <a:t>는 </a:t>
+            </a:r>
+            <a:r>
+              <a:rPr lang="en-US" altLang="ko-KR" sz="1400"/>
+              <a:t>PRD </a:t>
+            </a:r>
+            <a:r>
+              <a:rPr lang="ko-KR" altLang="en-US" sz="1400"/>
+              <a:t>문서의 </a:t>
+            </a:r>
+            <a:br>
+              <a:rPr lang="en-US" altLang="ko-KR" sz="1400"/>
+            </a:br>
+            <a:r>
+              <a:rPr lang="en-US" altLang="ko-KR" sz="1400"/>
+              <a:t>    </a:t>
+            </a:r>
+            <a:r>
+              <a:rPr lang="ko-KR" altLang="en-US" sz="1400"/>
+              <a:t>작성을 </a:t>
+            </a:r>
+            <a:r>
+              <a:rPr lang="en-US" altLang="ko-KR" sz="1400"/>
+              <a:t>Claude Code </a:t>
+            </a:r>
+            <a:r>
+              <a:rPr lang="ko-KR" altLang="en-US" sz="1400"/>
+              <a:t>에 요청한다</a:t>
+            </a:r>
+            <a:r>
+              <a:rPr lang="en-US" altLang="ko-KR" sz="1400"/>
+              <a:t>.</a:t>
+            </a:r>
+            <a:endParaRPr lang="ko-KR" altLang="en-US" sz="1400"/>
+          </a:p>
+        </p:txBody>
+      </p:sp>
+      <p:pic>
+        <p:nvPicPr>
+          <p:cNvPr id="9" name="그림 8">
+            <a:extLst>
+              <a:ext uri="{FF2B5EF4-FFF2-40B4-BE49-F238E27FC236}">
+                <a16:creationId xmlns:a16="http://schemas.microsoft.com/office/drawing/2014/main" id="{EE43C911-9ED2-A5C9-3DFB-0B2FC14B3CDC}"/>
+              </a:ext>
+            </a:extLst>
+          </p:cNvPr>
+          <p:cNvPicPr>
+            <a:picLocks noChangeAspect="1"/>
+          </p:cNvPicPr>
+          <p:nvPr/>
+        </p:nvPicPr>
+        <p:blipFill>
+          <a:blip r:embed="rId3"/>
+          <a:stretch>
+            <a:fillRect/>
+          </a:stretch>
+        </p:blipFill>
+        <p:spPr>
+          <a:xfrm>
+            <a:off x="5315805" y="2575437"/>
+            <a:ext cx="1783551" cy="1713760"/>
+          </a:xfrm>
+          <a:prstGeom prst="rect">
+            <a:avLst/>
+          </a:prstGeom>
+        </p:spPr>
+      </p:pic>
+      <p:pic>
+        <p:nvPicPr>
+          <p:cNvPr id="11" name="그림 10">
+            <a:extLst>
+              <a:ext uri="{FF2B5EF4-FFF2-40B4-BE49-F238E27FC236}">
+                <a16:creationId xmlns:a16="http://schemas.microsoft.com/office/drawing/2014/main" id="{092B97D7-8789-9E36-0014-C9C2D31AA074}"/>
+              </a:ext>
+            </a:extLst>
+          </p:cNvPr>
+          <p:cNvPicPr>
+            <a:picLocks noChangeAspect="1"/>
+          </p:cNvPicPr>
+          <p:nvPr/>
+        </p:nvPicPr>
+        <p:blipFill>
+          <a:blip r:embed="rId4"/>
+          <a:stretch>
+            <a:fillRect/>
+          </a:stretch>
+        </p:blipFill>
+        <p:spPr>
+          <a:xfrm>
+            <a:off x="7229661" y="2575436"/>
+            <a:ext cx="3335289" cy="2976952"/>
+          </a:xfrm>
+          <a:prstGeom prst="rect">
+            <a:avLst/>
+          </a:prstGeom>
+        </p:spPr>
+      </p:pic>
+      <p:sp>
+        <p:nvSpPr>
+          <p:cNvPr id="12" name="TextBox 11">
+            <a:extLst>
+              <a:ext uri="{FF2B5EF4-FFF2-40B4-BE49-F238E27FC236}">
+                <a16:creationId xmlns:a16="http://schemas.microsoft.com/office/drawing/2014/main" id="{21C80A81-C053-1A17-E55A-024B8858866A}"/>
+              </a:ext>
+            </a:extLst>
+          </p:cNvPr>
+          <p:cNvSpPr txBox="1"/>
+          <p:nvPr/>
+        </p:nvSpPr>
+        <p:spPr>
+          <a:xfrm>
+            <a:off x="5315805" y="5552388"/>
+            <a:ext cx="6693943" cy="1200329"/>
+          </a:xfrm>
+          <a:prstGeom prst="rect">
+            <a:avLst/>
+          </a:prstGeom>
+          <a:noFill/>
+        </p:spPr>
+        <p:txBody>
+          <a:bodyPr wrap="square" rtlCol="0">
+            <a:spAutoFit/>
+          </a:bodyPr>
+          <a:lstStyle/>
+          <a:p>
+            <a:r>
+              <a:rPr lang="en-US" altLang="ko-KR" sz="1200"/>
+              <a:t>Task Manager</a:t>
+            </a:r>
+            <a:r>
+              <a:rPr lang="ko-KR" altLang="en-US" sz="1200"/>
+              <a:t>는 </a:t>
+            </a:r>
+            <a:r>
+              <a:rPr lang="en-US" altLang="ko-KR" sz="1200"/>
+              <a:t>PRD </a:t>
+            </a:r>
+            <a:r>
+              <a:rPr lang="ko-KR" altLang="en-US" sz="1200"/>
+              <a:t>예제 샘플을 </a:t>
+            </a:r>
+            <a:r>
+              <a:rPr lang="en-US" altLang="ko-KR" sz="1200"/>
+              <a:t>.taskmaster/templates </a:t>
+            </a:r>
+            <a:r>
+              <a:rPr lang="ko-KR" altLang="en-US" sz="1200"/>
+              <a:t>폴더 내 제공한다</a:t>
+            </a:r>
+            <a:r>
+              <a:rPr lang="en-US" altLang="ko-KR" sz="1200"/>
+              <a:t>.</a:t>
+            </a:r>
+            <a:br>
+              <a:rPr lang="en-US" altLang="ko-KR" sz="1200"/>
+            </a:br>
+            <a:r>
+              <a:rPr lang="ko-KR" altLang="en-US" sz="1200"/>
+              <a:t>해당 파일도 </a:t>
+            </a:r>
+            <a:r>
+              <a:rPr lang="en-US" altLang="ko-KR" sz="1200"/>
+              <a:t>PRD </a:t>
+            </a:r>
+            <a:r>
+              <a:rPr lang="ko-KR" altLang="en-US" sz="1200"/>
+              <a:t>요청과 함께 </a:t>
+            </a:r>
+            <a:r>
+              <a:rPr lang="en-US" altLang="ko-KR" sz="1200"/>
+              <a:t>Claude Code </a:t>
+            </a:r>
+            <a:r>
+              <a:rPr lang="ko-KR" altLang="en-US" sz="1200"/>
+              <a:t>에 제공하여</a:t>
+            </a:r>
+            <a:r>
+              <a:rPr lang="en-US" altLang="ko-KR" sz="1200"/>
+              <a:t>, </a:t>
+            </a:r>
+            <a:r>
+              <a:rPr lang="ko-KR" altLang="en-US" sz="1200"/>
+              <a:t>일관된 </a:t>
+            </a:r>
+            <a:r>
+              <a:rPr lang="en-US" altLang="ko-KR" sz="1200"/>
+              <a:t>PRD</a:t>
+            </a:r>
+            <a:r>
+              <a:rPr lang="ko-KR" altLang="en-US" sz="1200"/>
+              <a:t>를 얻는데 </a:t>
+            </a:r>
+            <a:br>
+              <a:rPr lang="en-US" altLang="ko-KR" sz="1200"/>
+            </a:br>
+            <a:r>
+              <a:rPr lang="ko-KR" altLang="en-US" sz="1200"/>
+              <a:t>기여할 수 있다</a:t>
+            </a:r>
+            <a:r>
+              <a:rPr lang="en-US" altLang="ko-KR" sz="1200"/>
+              <a:t>.</a:t>
+            </a:r>
+            <a:br>
+              <a:rPr lang="en-US" altLang="ko-KR" sz="1200"/>
+            </a:br>
+            <a:br>
+              <a:rPr lang="en-US" altLang="ko-KR" sz="1200"/>
+            </a:br>
+            <a:r>
+              <a:rPr lang="en-US" altLang="ko-KR" sz="1200"/>
+              <a:t>※ PRD </a:t>
+            </a:r>
+            <a:r>
+              <a:rPr lang="ko-KR" altLang="en-US" sz="1200"/>
+              <a:t>문서는 잘못된 정보가 없는지 절차적으로 문제가 없는지 꼼꼼히 살펴보고</a:t>
+            </a:r>
+            <a:br>
+              <a:rPr lang="en-US" altLang="ko-KR" sz="1200"/>
+            </a:br>
+            <a:r>
+              <a:rPr lang="en-US" altLang="ko-KR" sz="1200"/>
+              <a:t>    </a:t>
+            </a:r>
+            <a:r>
+              <a:rPr lang="ko-KR" altLang="en-US" sz="1200"/>
+              <a:t>계획</a:t>
+            </a:r>
+            <a:r>
+              <a:rPr lang="en-US" altLang="ko-KR" sz="1200"/>
+              <a:t>(</a:t>
+            </a:r>
+            <a:r>
+              <a:rPr lang="ko-KR" altLang="en-US" sz="1200"/>
+              <a:t>작업 </a:t>
+            </a:r>
+            <a:r>
+              <a:rPr lang="en-US" altLang="ko-KR" sz="1200"/>
+              <a:t>= Task)</a:t>
+            </a:r>
+            <a:r>
+              <a:rPr lang="ko-KR" altLang="en-US" sz="1200"/>
+              <a:t>을 작성을 요청해야한다</a:t>
+            </a:r>
+            <a:r>
+              <a:rPr lang="en-US" altLang="ko-KR" sz="1200"/>
+              <a:t>.</a:t>
+            </a:r>
+            <a:endParaRPr lang="ko-KR" altLang="en-US" sz="1200"/>
+          </a:p>
+        </p:txBody>
+      </p:sp>
+    </p:spTree>
+    <p:extLst>
+      <p:ext uri="{BB962C8B-B14F-4D97-AF65-F5344CB8AC3E}">
+        <p14:creationId xmlns:p14="http://schemas.microsoft.com/office/powerpoint/2010/main" val="2083399180"/>
+      </p:ext>
+    </p:extLst>
+  </p:cSld>
+  <p:clrMapOvr>
+    <a:masterClrMapping/>
+  </p:clrMapOvr>
+</p:sld>
+</file>
+
+<file path=ppt/slides/slide14.xml><?xml version="1.0" encoding="utf-8"?>
+<p:sld xmlns:a="http://schemas.openxmlformats.org/drawingml/2006/main" xmlns:r="http://schemas.openxmlformats.org/officeDocument/2006/relationships" xmlns:p="http://schemas.openxmlformats.org/presentationml/2006/main">
+  <p:cSld>
+    <p:spTree>
+      <p:nvGrpSpPr>
+        <p:cNvPr id="1" name=""/>
+        <p:cNvGrpSpPr/>
+        <p:nvPr/>
+      </p:nvGrpSpPr>
+      <p:grpSpPr>
+        <a:xfrm>
+          <a:off x="0" y="0"/>
+          <a:ext cx="0" cy="0"/>
+          <a:chOff x="0" y="0"/>
+          <a:chExt cx="0" cy="0"/>
+        </a:xfrm>
+      </p:grpSpPr>
+      <p:sp>
+        <p:nvSpPr>
+          <p:cNvPr id="2" name="제목 1">
+            <a:extLst>
+              <a:ext uri="{FF2B5EF4-FFF2-40B4-BE49-F238E27FC236}">
+                <a16:creationId xmlns:a16="http://schemas.microsoft.com/office/drawing/2014/main" id="{26BA0D2B-6D5B-FA37-7FA4-EF2474479C5B}"/>
+              </a:ext>
+            </a:extLst>
+          </p:cNvPr>
+          <p:cNvSpPr>
+            <a:spLocks noGrp="1"/>
+          </p:cNvSpPr>
+          <p:nvPr>
+            <p:ph type="title"/>
+          </p:nvPr>
+        </p:nvSpPr>
+        <p:spPr/>
+        <p:txBody>
+          <a:bodyPr/>
+          <a:lstStyle/>
+          <a:p>
+            <a:r>
+              <a:rPr lang="en-US" altLang="ko-KR"/>
+              <a:t>Task Master Task</a:t>
+            </a:r>
+            <a:r>
+              <a:rPr lang="ko-KR" altLang="en-US"/>
+              <a:t> 생성</a:t>
+            </a:r>
+          </a:p>
+        </p:txBody>
+      </p:sp>
+      <p:sp>
+        <p:nvSpPr>
+          <p:cNvPr id="3" name="TextBox 2">
+            <a:extLst>
+              <a:ext uri="{FF2B5EF4-FFF2-40B4-BE49-F238E27FC236}">
+                <a16:creationId xmlns:a16="http://schemas.microsoft.com/office/drawing/2014/main" id="{E1A251D1-6C53-C03F-58B4-0E0103FDDBA3}"/>
+              </a:ext>
+            </a:extLst>
+          </p:cNvPr>
+          <p:cNvSpPr txBox="1"/>
+          <p:nvPr/>
+        </p:nvSpPr>
+        <p:spPr>
+          <a:xfrm>
+            <a:off x="1084082" y="1904214"/>
+            <a:ext cx="10086681" cy="1169551"/>
+          </a:xfrm>
+          <a:prstGeom prst="rect">
+            <a:avLst/>
+          </a:prstGeom>
+          <a:noFill/>
+        </p:spPr>
+        <p:txBody>
+          <a:bodyPr wrap="square" rtlCol="0">
+            <a:spAutoFit/>
+          </a:bodyPr>
+          <a:lstStyle/>
+          <a:p>
+            <a:r>
+              <a:rPr lang="en-US" altLang="ko-KR" sz="1400">
+                <a:solidFill>
+                  <a:srgbClr val="FF0000"/>
+                </a:solidFill>
+              </a:rPr>
+              <a:t>@.taskmaster </a:t>
+            </a:r>
+            <a:r>
+              <a:rPr lang="en-US" altLang="ko-KR" sz="1400">
+                <a:solidFill>
+                  <a:srgbClr val="0000FF"/>
+                </a:solidFill>
+              </a:rPr>
+              <a:t>tm parse-prd </a:t>
+            </a:r>
+            <a:r>
+              <a:rPr lang="en-US" altLang="ko-KR" sz="1400"/>
+              <a:t>${path/prd.txt} </a:t>
+            </a:r>
+            <a:r>
+              <a:rPr lang="en-US" altLang="ko-KR" sz="1400">
+                <a:sym typeface="Wingdings" panose="05000000000000000000" pitchFamily="2" charset="2"/>
+              </a:rPr>
+              <a:t> PRD</a:t>
+            </a:r>
+            <a:r>
+              <a:rPr lang="ko-KR" altLang="en-US" sz="1400">
+                <a:sym typeface="Wingdings" panose="05000000000000000000" pitchFamily="2" charset="2"/>
+              </a:rPr>
+              <a:t> 파싱으로 </a:t>
+            </a:r>
+            <a:r>
+              <a:rPr lang="en-US" altLang="ko-KR" sz="1400">
+                <a:sym typeface="Wingdings" panose="05000000000000000000" pitchFamily="2" charset="2"/>
+              </a:rPr>
+              <a:t>Task </a:t>
+            </a:r>
+            <a:r>
+              <a:rPr lang="ko-KR" altLang="en-US" sz="1400">
+                <a:sym typeface="Wingdings" panose="05000000000000000000" pitchFamily="2" charset="2"/>
+              </a:rPr>
+              <a:t>생성 명령어</a:t>
+            </a:r>
+            <a:endParaRPr lang="en-US" altLang="ko-KR" sz="1400">
+              <a:sym typeface="Wingdings" panose="05000000000000000000" pitchFamily="2" charset="2"/>
+            </a:endParaRPr>
+          </a:p>
+          <a:p>
+            <a:endParaRPr lang="en-US" altLang="ko-KR" sz="1400"/>
+          </a:p>
+          <a:p>
+            <a:r>
+              <a:rPr lang="en-US" altLang="ko-KR" sz="1400" b="1"/>
+              <a:t>CLI </a:t>
+            </a:r>
+            <a:r>
+              <a:rPr lang="ko-KR" altLang="en-US" sz="1400" b="1"/>
+              <a:t>로 </a:t>
+            </a:r>
+            <a:r>
+              <a:rPr lang="en-US" altLang="ko-KR" sz="1400" b="1"/>
+              <a:t>Task Master</a:t>
+            </a:r>
+            <a:r>
+              <a:rPr lang="ko-KR" altLang="en-US" sz="1400" b="1"/>
+              <a:t>를 사용할 경우 </a:t>
+            </a:r>
+            <a:r>
+              <a:rPr lang="en-US" altLang="ko-KR" sz="1400" b="1"/>
+              <a:t>.env </a:t>
+            </a:r>
+            <a:r>
+              <a:rPr lang="ko-KR" altLang="en-US" sz="1400" b="1"/>
+              <a:t>파일에 </a:t>
+            </a:r>
+            <a:r>
+              <a:rPr lang="en-US" altLang="ko-KR" sz="1400" b="1"/>
+              <a:t>API Key </a:t>
+            </a:r>
+            <a:r>
+              <a:rPr lang="ko-KR" altLang="en-US" sz="1400" b="1"/>
+              <a:t>가 존재해야한다</a:t>
+            </a:r>
+            <a:r>
+              <a:rPr lang="en-US" altLang="ko-KR" sz="1400" b="1"/>
+              <a:t>. </a:t>
+            </a:r>
+            <a:br>
+              <a:rPr lang="en-US" altLang="ko-KR" sz="1400"/>
+            </a:br>
+            <a:r>
+              <a:rPr lang="en-US" altLang="ko-KR" sz="1400">
+                <a:sym typeface="Wingdings" panose="05000000000000000000" pitchFamily="2" charset="2"/>
+              </a:rPr>
+              <a:t> </a:t>
+            </a:r>
+            <a:r>
+              <a:rPr lang="ko-KR" altLang="en-US" sz="1400">
+                <a:sym typeface="Wingdings" panose="05000000000000000000" pitchFamily="2" charset="2"/>
+              </a:rPr>
+              <a:t>그러나 </a:t>
+            </a:r>
+            <a:r>
+              <a:rPr lang="en-US" altLang="ko-KR" sz="1400">
+                <a:sym typeface="Wingdings" panose="05000000000000000000" pitchFamily="2" charset="2"/>
+              </a:rPr>
+              <a:t>claude code </a:t>
+            </a:r>
+            <a:r>
+              <a:rPr lang="ko-KR" altLang="en-US" sz="1400">
+                <a:sym typeface="Wingdings" panose="05000000000000000000" pitchFamily="2" charset="2"/>
+              </a:rPr>
+              <a:t>로 함으로 </a:t>
+            </a:r>
+            <a:r>
+              <a:rPr lang="en-US" altLang="ko-KR" sz="1400">
+                <a:sym typeface="Wingdings" panose="05000000000000000000" pitchFamily="2" charset="2"/>
+              </a:rPr>
+              <a:t>API Key </a:t>
+            </a:r>
+            <a:r>
+              <a:rPr lang="ko-KR" altLang="en-US" sz="1400">
+                <a:sym typeface="Wingdings" panose="05000000000000000000" pitchFamily="2" charset="2"/>
+              </a:rPr>
+              <a:t>자체가 없음</a:t>
+            </a:r>
+            <a:r>
+              <a:rPr lang="en-US" altLang="ko-KR" sz="1400">
+                <a:sym typeface="Wingdings" panose="05000000000000000000" pitchFamily="2" charset="2"/>
+              </a:rPr>
+              <a:t>. (</a:t>
+            </a:r>
+            <a:r>
+              <a:rPr lang="ko-KR" altLang="en-US" sz="1400">
+                <a:sym typeface="Wingdings" panose="05000000000000000000" pitchFamily="2" charset="2"/>
+              </a:rPr>
+              <a:t>만약 </a:t>
+            </a:r>
+            <a:r>
+              <a:rPr lang="en-US" altLang="ko-KR" sz="1400">
+                <a:sym typeface="Wingdings" panose="05000000000000000000" pitchFamily="2" charset="2"/>
+              </a:rPr>
+              <a:t>API</a:t>
+            </a:r>
+            <a:r>
+              <a:rPr lang="ko-KR" altLang="en-US" sz="1400">
+                <a:sym typeface="Wingdings" panose="05000000000000000000" pitchFamily="2" charset="2"/>
+              </a:rPr>
+              <a:t>로 사용량에 따른 요금 결제를 원할 시에 참고</a:t>
+            </a:r>
+            <a:r>
+              <a:rPr lang="en-US" altLang="ko-KR" sz="1400">
+                <a:sym typeface="Wingdings" panose="05000000000000000000" pitchFamily="2" charset="2"/>
+              </a:rPr>
+              <a:t>)</a:t>
+            </a:r>
+          </a:p>
+          <a:p>
+            <a:endParaRPr lang="ko-KR" altLang="en-US" sz="1400"/>
+          </a:p>
+        </p:txBody>
+      </p:sp>
+      <p:pic>
+        <p:nvPicPr>
+          <p:cNvPr id="5" name="그림 4">
+            <a:extLst>
+              <a:ext uri="{FF2B5EF4-FFF2-40B4-BE49-F238E27FC236}">
+                <a16:creationId xmlns:a16="http://schemas.microsoft.com/office/drawing/2014/main" id="{A57FEA33-B6AD-DF41-A58B-87E87B6B5132}"/>
+              </a:ext>
+            </a:extLst>
+          </p:cNvPr>
+          <p:cNvPicPr>
+            <a:picLocks noChangeAspect="1"/>
+          </p:cNvPicPr>
+          <p:nvPr/>
+        </p:nvPicPr>
+        <p:blipFill>
+          <a:blip r:embed="rId2"/>
+          <a:stretch>
+            <a:fillRect/>
+          </a:stretch>
+        </p:blipFill>
+        <p:spPr>
+          <a:xfrm>
+            <a:off x="1097280" y="3073765"/>
+            <a:ext cx="6782747" cy="657317"/>
+          </a:xfrm>
+          <a:prstGeom prst="rect">
+            <a:avLst/>
+          </a:prstGeom>
+        </p:spPr>
+      </p:pic>
+      <p:pic>
+        <p:nvPicPr>
+          <p:cNvPr id="9" name="그림 8">
+            <a:extLst>
+              <a:ext uri="{FF2B5EF4-FFF2-40B4-BE49-F238E27FC236}">
+                <a16:creationId xmlns:a16="http://schemas.microsoft.com/office/drawing/2014/main" id="{E3CD92F3-96BB-1698-DC19-D5F4429FA1DC}"/>
+              </a:ext>
+            </a:extLst>
+          </p:cNvPr>
+          <p:cNvPicPr>
+            <a:picLocks noChangeAspect="1"/>
+          </p:cNvPicPr>
+          <p:nvPr/>
+        </p:nvPicPr>
+        <p:blipFill>
+          <a:blip r:embed="rId3"/>
+          <a:stretch>
+            <a:fillRect/>
+          </a:stretch>
+        </p:blipFill>
+        <p:spPr>
+          <a:xfrm>
+            <a:off x="1097281" y="3869077"/>
+            <a:ext cx="6796778" cy="2230065"/>
+          </a:xfrm>
+          <a:prstGeom prst="rect">
+            <a:avLst/>
+          </a:prstGeom>
+        </p:spPr>
+      </p:pic>
+      <p:sp>
+        <p:nvSpPr>
+          <p:cNvPr id="10" name="TextBox 9">
+            <a:extLst>
+              <a:ext uri="{FF2B5EF4-FFF2-40B4-BE49-F238E27FC236}">
+                <a16:creationId xmlns:a16="http://schemas.microsoft.com/office/drawing/2014/main" id="{01DFC63F-F1F1-DA53-1874-9D03770813AF}"/>
+              </a:ext>
+            </a:extLst>
+          </p:cNvPr>
+          <p:cNvSpPr txBox="1"/>
+          <p:nvPr/>
+        </p:nvSpPr>
+        <p:spPr>
+          <a:xfrm>
+            <a:off x="7894059" y="3869077"/>
+            <a:ext cx="4049702" cy="1046440"/>
+          </a:xfrm>
+          <a:prstGeom prst="rect">
+            <a:avLst/>
+          </a:prstGeom>
+          <a:noFill/>
+        </p:spPr>
+        <p:txBody>
+          <a:bodyPr wrap="square" rtlCol="0">
+            <a:spAutoFit/>
+          </a:bodyPr>
+          <a:lstStyle/>
+          <a:p>
+            <a:r>
+              <a:rPr lang="en-US" altLang="ko-KR" sz="1400"/>
+              <a:t>task</a:t>
+            </a:r>
+            <a:r>
+              <a:rPr lang="ko-KR" altLang="en-US" sz="1400"/>
+              <a:t> 생성 결과</a:t>
+            </a:r>
+            <a:br>
+              <a:rPr lang="en-US" altLang="ko-KR" sz="1400"/>
+            </a:br>
+            <a:br>
+              <a:rPr lang="en-US" altLang="ko-KR" sz="1200"/>
+            </a:br>
+            <a:r>
+              <a:rPr lang="en-US" altLang="ko-KR" sz="1200"/>
+              <a:t>@.task-master </a:t>
+            </a:r>
+            <a:r>
+              <a:rPr lang="en-US" altLang="ko-KR" sz="1200">
+                <a:solidFill>
+                  <a:srgbClr val="0000FF"/>
+                </a:solidFill>
+              </a:rPr>
+              <a:t>tm list </a:t>
+            </a:r>
+            <a:r>
+              <a:rPr lang="en-US" altLang="ko-KR" sz="1200">
+                <a:sym typeface="Wingdings" panose="05000000000000000000" pitchFamily="2" charset="2"/>
+              </a:rPr>
+              <a:t> </a:t>
+            </a:r>
+            <a:r>
+              <a:rPr lang="ko-KR" altLang="en-US" sz="1200">
+                <a:sym typeface="Wingdings" panose="05000000000000000000" pitchFamily="2" charset="2"/>
+              </a:rPr>
+              <a:t>작업 목록 확인</a:t>
+            </a:r>
+            <a:endParaRPr lang="en-US" altLang="ko-KR" sz="1200">
+              <a:sym typeface="Wingdings" panose="05000000000000000000" pitchFamily="2" charset="2"/>
+            </a:endParaRPr>
+          </a:p>
+          <a:p>
+            <a:r>
+              <a:rPr lang="en-US" altLang="ko-KR" sz="1200">
+                <a:sym typeface="Wingdings" panose="05000000000000000000" pitchFamily="2" charset="2"/>
+              </a:rPr>
+              <a:t>@.task-master</a:t>
+            </a:r>
+            <a:r>
+              <a:rPr lang="ko-KR" altLang="en-US" sz="1200">
+                <a:sym typeface="Wingdings" panose="05000000000000000000" pitchFamily="2" charset="2"/>
+              </a:rPr>
+              <a:t> </a:t>
+            </a:r>
+            <a:r>
+              <a:rPr lang="en-US" altLang="ko-KR" sz="1200">
+                <a:solidFill>
+                  <a:srgbClr val="0000FF"/>
+                </a:solidFill>
+                <a:sym typeface="Wingdings" panose="05000000000000000000" pitchFamily="2" charset="2"/>
+              </a:rPr>
+              <a:t>tm</a:t>
+            </a:r>
+            <a:r>
+              <a:rPr lang="ko-KR" altLang="en-US" sz="1200">
+                <a:solidFill>
+                  <a:srgbClr val="0000FF"/>
+                </a:solidFill>
+                <a:sym typeface="Wingdings" panose="05000000000000000000" pitchFamily="2" charset="2"/>
+              </a:rPr>
+              <a:t> </a:t>
+            </a:r>
+            <a:r>
+              <a:rPr lang="en-US" altLang="ko-KR" sz="1200">
+                <a:solidFill>
+                  <a:srgbClr val="0000FF"/>
+                </a:solidFill>
+                <a:sym typeface="Wingdings" panose="05000000000000000000" pitchFamily="2" charset="2"/>
+              </a:rPr>
+              <a:t>expend</a:t>
+            </a:r>
+            <a:r>
+              <a:rPr lang="ko-KR" altLang="en-US" sz="1200">
+                <a:solidFill>
+                  <a:srgbClr val="0000FF"/>
+                </a:solidFill>
+                <a:sym typeface="Wingdings" panose="05000000000000000000" pitchFamily="2" charset="2"/>
+              </a:rPr>
+              <a:t> </a:t>
+            </a:r>
+            <a:r>
+              <a:rPr lang="en-US" altLang="ko-KR" sz="1200">
+                <a:solidFill>
+                  <a:srgbClr val="0000FF"/>
+                </a:solidFill>
+                <a:sym typeface="Wingdings" panose="05000000000000000000" pitchFamily="2" charset="2"/>
+              </a:rPr>
+              <a:t>--id=&lt;id&gt;</a:t>
+            </a:r>
+            <a:r>
+              <a:rPr lang="en-US" altLang="ko-KR" sz="1200">
+                <a:sym typeface="Wingdings" panose="05000000000000000000" pitchFamily="2" charset="2"/>
+              </a:rPr>
+              <a:t>  </a:t>
+            </a:r>
+            <a:br>
+              <a:rPr lang="en-US" altLang="ko-KR" sz="1200">
+                <a:sym typeface="Wingdings" panose="05000000000000000000" pitchFamily="2" charset="2"/>
+              </a:rPr>
+            </a:br>
+            <a:r>
+              <a:rPr lang="en-US" altLang="ko-KR" sz="1200">
+                <a:sym typeface="Wingdings" panose="05000000000000000000" pitchFamily="2" charset="2"/>
+              </a:rPr>
+              <a:t>     </a:t>
+            </a:r>
+            <a:r>
+              <a:rPr lang="ko-KR" altLang="en-US" sz="1200">
+                <a:sym typeface="Wingdings" panose="05000000000000000000" pitchFamily="2" charset="2"/>
+              </a:rPr>
+              <a:t>작업 번호에 대한 세부 작업 분할 </a:t>
+            </a:r>
+            <a:endParaRPr lang="ko-KR" altLang="en-US" sz="1200"/>
+          </a:p>
+        </p:txBody>
+      </p:sp>
+    </p:spTree>
+    <p:extLst>
+      <p:ext uri="{BB962C8B-B14F-4D97-AF65-F5344CB8AC3E}">
+        <p14:creationId xmlns:p14="http://schemas.microsoft.com/office/powerpoint/2010/main" val="1763418462"/>
+      </p:ext>
+    </p:extLst>
+  </p:cSld>
+  <p:clrMapOvr>
+    <a:masterClrMapping/>
+  </p:clrMapOvr>
+</p:sld>
+</file>
+
+<file path=ppt/slides/slide15.xml><?xml version="1.0" encoding="utf-8"?>
+<p:sld xmlns:a="http://schemas.openxmlformats.org/drawingml/2006/main" xmlns:r="http://schemas.openxmlformats.org/officeDocument/2006/relationships" xmlns:p="http://schemas.openxmlformats.org/presentationml/2006/main">
+  <p:cSld>
+    <p:spTree>
+      <p:nvGrpSpPr>
+        <p:cNvPr id="1" name=""/>
+        <p:cNvGrpSpPr/>
+        <p:nvPr/>
+      </p:nvGrpSpPr>
+      <p:grpSpPr>
+        <a:xfrm>
+          <a:off x="0" y="0"/>
+          <a:ext cx="0" cy="0"/>
+          <a:chOff x="0" y="0"/>
+          <a:chExt cx="0" cy="0"/>
+        </a:xfrm>
+      </p:grpSpPr>
+      <p:sp>
+        <p:nvSpPr>
+          <p:cNvPr id="2" name="제목 1">
+            <a:extLst>
+              <a:ext uri="{FF2B5EF4-FFF2-40B4-BE49-F238E27FC236}">
+                <a16:creationId xmlns:a16="http://schemas.microsoft.com/office/drawing/2014/main" id="{1A2D5464-B8C8-3B1D-D736-70A0BE91EDE3}"/>
+              </a:ext>
+            </a:extLst>
+          </p:cNvPr>
+          <p:cNvSpPr>
+            <a:spLocks noGrp="1"/>
+          </p:cNvSpPr>
+          <p:nvPr>
+            <p:ph type="title"/>
+          </p:nvPr>
+        </p:nvSpPr>
+        <p:spPr/>
+        <p:txBody>
+          <a:bodyPr/>
+          <a:lstStyle/>
+          <a:p>
+            <a:r>
+              <a:rPr lang="en-US" altLang="ko-KR"/>
+              <a:t>Task Master List </a:t>
+            </a:r>
+            <a:r>
+              <a:rPr lang="ko-KR" altLang="en-US"/>
+              <a:t>확인</a:t>
+            </a:r>
+          </a:p>
+        </p:txBody>
+      </p:sp>
+      <p:pic>
+        <p:nvPicPr>
+          <p:cNvPr id="4" name="그림 3">
+            <a:extLst>
+              <a:ext uri="{FF2B5EF4-FFF2-40B4-BE49-F238E27FC236}">
+                <a16:creationId xmlns:a16="http://schemas.microsoft.com/office/drawing/2014/main" id="{56C5E410-E977-09FA-BCD8-7178F22E67A2}"/>
+              </a:ext>
+            </a:extLst>
+          </p:cNvPr>
+          <p:cNvPicPr>
+            <a:picLocks noChangeAspect="1"/>
+          </p:cNvPicPr>
+          <p:nvPr/>
+        </p:nvPicPr>
+        <p:blipFill>
+          <a:blip r:embed="rId2"/>
+          <a:stretch>
+            <a:fillRect/>
+          </a:stretch>
+        </p:blipFill>
+        <p:spPr>
+          <a:xfrm>
+            <a:off x="299299" y="1942281"/>
+            <a:ext cx="7068536" cy="3991532"/>
+          </a:xfrm>
+          <a:prstGeom prst="rect">
+            <a:avLst/>
+          </a:prstGeom>
+        </p:spPr>
+      </p:pic>
+      <p:sp>
+        <p:nvSpPr>
+          <p:cNvPr id="5" name="TextBox 4">
+            <a:extLst>
+              <a:ext uri="{FF2B5EF4-FFF2-40B4-BE49-F238E27FC236}">
+                <a16:creationId xmlns:a16="http://schemas.microsoft.com/office/drawing/2014/main" id="{FBF73B1A-60DD-1E3D-B594-06667FC6F804}"/>
+              </a:ext>
+            </a:extLst>
+          </p:cNvPr>
+          <p:cNvSpPr txBox="1"/>
+          <p:nvPr/>
+        </p:nvSpPr>
+        <p:spPr>
+          <a:xfrm>
+            <a:off x="7475456" y="1942281"/>
+            <a:ext cx="4515439" cy="830997"/>
+          </a:xfrm>
+          <a:prstGeom prst="rect">
+            <a:avLst/>
+          </a:prstGeom>
+          <a:noFill/>
+        </p:spPr>
+        <p:txBody>
+          <a:bodyPr wrap="square" rtlCol="0">
+            <a:spAutoFit/>
+          </a:bodyPr>
+          <a:lstStyle/>
+          <a:p>
+            <a:r>
+              <a:rPr lang="en-US" altLang="ko-KR" sz="1200">
+                <a:solidFill>
+                  <a:srgbClr val="FF0000"/>
+                </a:solidFill>
+              </a:rPr>
+              <a:t>@.taskmaster</a:t>
+            </a:r>
+            <a:r>
+              <a:rPr lang="ko-KR" altLang="en-US" sz="1200">
+                <a:solidFill>
+                  <a:srgbClr val="FF0000"/>
+                </a:solidFill>
+              </a:rPr>
+              <a:t> </a:t>
+            </a:r>
+            <a:r>
+              <a:rPr lang="en-US" altLang="ko-KR" sz="1200">
+                <a:solidFill>
+                  <a:srgbClr val="0000FF"/>
+                </a:solidFill>
+              </a:rPr>
+              <a:t>tm</a:t>
+            </a:r>
+            <a:r>
+              <a:rPr lang="ko-KR" altLang="en-US" sz="1200">
+                <a:solidFill>
+                  <a:srgbClr val="0000FF"/>
+                </a:solidFill>
+              </a:rPr>
+              <a:t> </a:t>
+            </a:r>
+            <a:r>
+              <a:rPr lang="en-US" altLang="ko-KR" sz="1200">
+                <a:solidFill>
+                  <a:srgbClr val="0000FF"/>
+                </a:solidFill>
+              </a:rPr>
+              <a:t>list</a:t>
+            </a:r>
+            <a:r>
+              <a:rPr lang="ko-KR" altLang="en-US" sz="1200">
+                <a:solidFill>
+                  <a:srgbClr val="0000FF"/>
+                </a:solidFill>
+              </a:rPr>
+              <a:t> </a:t>
+            </a:r>
+            <a:endParaRPr lang="en-US" altLang="ko-KR" sz="1200">
+              <a:solidFill>
+                <a:srgbClr val="0000FF"/>
+              </a:solidFill>
+            </a:endParaRPr>
+          </a:p>
+          <a:p>
+            <a:r>
+              <a:rPr lang="en-US" altLang="ko-KR" sz="1200">
+                <a:sym typeface="Wingdings" panose="05000000000000000000" pitchFamily="2" charset="2"/>
+              </a:rPr>
+              <a:t> </a:t>
+            </a:r>
+            <a:r>
+              <a:rPr lang="ko-KR" altLang="en-US" sz="1200">
+                <a:sym typeface="Wingdings" panose="05000000000000000000" pitchFamily="2" charset="2"/>
+              </a:rPr>
+              <a:t>해당 명령을 통해 작업순서</a:t>
+            </a:r>
+            <a:r>
+              <a:rPr lang="en-US" altLang="ko-KR" sz="1200">
+                <a:sym typeface="Wingdings" panose="05000000000000000000" pitchFamily="2" charset="2"/>
+              </a:rPr>
+              <a:t>, </a:t>
+            </a:r>
+            <a:r>
+              <a:rPr lang="ko-KR" altLang="en-US" sz="1200">
+                <a:sym typeface="Wingdings" panose="05000000000000000000" pitchFamily="2" charset="2"/>
+              </a:rPr>
+              <a:t>타이틀</a:t>
+            </a:r>
+            <a:r>
+              <a:rPr lang="en-US" altLang="ko-KR" sz="1200">
+                <a:sym typeface="Wingdings" panose="05000000000000000000" pitchFamily="2" charset="2"/>
+              </a:rPr>
+              <a:t>,  </a:t>
+            </a:r>
+            <a:r>
+              <a:rPr lang="ko-KR" altLang="en-US" sz="1200">
+                <a:sym typeface="Wingdings" panose="05000000000000000000" pitchFamily="2" charset="2"/>
+              </a:rPr>
+              <a:t>상태</a:t>
+            </a:r>
+            <a:r>
+              <a:rPr lang="en-US" altLang="ko-KR" sz="1200">
+                <a:sym typeface="Wingdings" panose="05000000000000000000" pitchFamily="2" charset="2"/>
+              </a:rPr>
+              <a:t>, </a:t>
+            </a:r>
+            <a:r>
+              <a:rPr lang="ko-KR" altLang="en-US" sz="1200">
+                <a:sym typeface="Wingdings" panose="05000000000000000000" pitchFamily="2" charset="2"/>
+              </a:rPr>
+              <a:t>우선순위</a:t>
+            </a:r>
+            <a:r>
+              <a:rPr lang="en-US" altLang="ko-KR" sz="1200">
+                <a:sym typeface="Wingdings" panose="05000000000000000000" pitchFamily="2" charset="2"/>
+              </a:rPr>
+              <a:t>, </a:t>
+            </a:r>
+            <a:r>
+              <a:rPr lang="ko-KR" altLang="en-US" sz="1200">
+                <a:sym typeface="Wingdings" panose="05000000000000000000" pitchFamily="2" charset="2"/>
+              </a:rPr>
+              <a:t>의존작업</a:t>
+            </a:r>
+            <a:br>
+              <a:rPr lang="en-US" altLang="ko-KR" sz="1200">
+                <a:sym typeface="Wingdings" panose="05000000000000000000" pitchFamily="2" charset="2"/>
+              </a:rPr>
+            </a:br>
+            <a:r>
+              <a:rPr lang="en-US" altLang="ko-KR" sz="1200">
+                <a:sym typeface="Wingdings" panose="05000000000000000000" pitchFamily="2" charset="2"/>
+              </a:rPr>
+              <a:t>    </a:t>
+            </a:r>
+            <a:r>
+              <a:rPr lang="ko-KR" altLang="en-US" sz="1200">
+                <a:sym typeface="Wingdings" panose="05000000000000000000" pitchFamily="2" charset="2"/>
+              </a:rPr>
+              <a:t>으로 확인할 수 있다</a:t>
+            </a:r>
+            <a:r>
+              <a:rPr lang="en-US" altLang="ko-KR" sz="1200">
+                <a:sym typeface="Wingdings" panose="05000000000000000000" pitchFamily="2" charset="2"/>
+              </a:rPr>
+              <a:t>.</a:t>
+            </a:r>
+            <a:br>
+              <a:rPr lang="en-US" altLang="ko-KR" sz="1200">
+                <a:sym typeface="Wingdings" panose="05000000000000000000" pitchFamily="2" charset="2"/>
+              </a:rPr>
+            </a:br>
+            <a:endParaRPr lang="ko-KR" altLang="en-US" sz="1200"/>
+          </a:p>
+        </p:txBody>
+      </p:sp>
+    </p:spTree>
+    <p:extLst>
+      <p:ext uri="{BB962C8B-B14F-4D97-AF65-F5344CB8AC3E}">
+        <p14:creationId xmlns:p14="http://schemas.microsoft.com/office/powerpoint/2010/main" val="1859165149"/>
+      </p:ext>
+    </p:extLst>
+  </p:cSld>
+  <p:clrMapOvr>
+    <a:masterClrMapping/>
+  </p:clrMapOvr>
+</p:sld>
+</file>
+
+<file path=ppt/slides/slide16.xml><?xml version="1.0" encoding="utf-8"?>
+<p:sld xmlns:a="http://schemas.openxmlformats.org/drawingml/2006/main" xmlns:r="http://schemas.openxmlformats.org/officeDocument/2006/relationships" xmlns:p="http://schemas.openxmlformats.org/presentationml/2006/main">
+  <p:cSld>
+    <p:spTree>
+      <p:nvGrpSpPr>
+        <p:cNvPr id="1" name=""/>
+        <p:cNvGrpSpPr/>
+        <p:nvPr/>
+      </p:nvGrpSpPr>
+      <p:grpSpPr>
+        <a:xfrm>
+          <a:off x="0" y="0"/>
+          <a:ext cx="0" cy="0"/>
+          <a:chOff x="0" y="0"/>
+          <a:chExt cx="0" cy="0"/>
+        </a:xfrm>
+      </p:grpSpPr>
+      <p:sp>
+        <p:nvSpPr>
+          <p:cNvPr id="2" name="제목 1">
+            <a:extLst>
+              <a:ext uri="{FF2B5EF4-FFF2-40B4-BE49-F238E27FC236}">
+                <a16:creationId xmlns:a16="http://schemas.microsoft.com/office/drawing/2014/main" id="{E5894F33-F6AE-A56D-C41C-31E69ADF1D8F}"/>
+              </a:ext>
+            </a:extLst>
+          </p:cNvPr>
+          <p:cNvSpPr>
+            <a:spLocks noGrp="1"/>
+          </p:cNvSpPr>
+          <p:nvPr>
+            <p:ph type="title"/>
+          </p:nvPr>
+        </p:nvSpPr>
+        <p:spPr/>
+        <p:txBody>
+          <a:bodyPr/>
+          <a:lstStyle/>
+          <a:p>
+            <a:r>
+              <a:rPr lang="en-US" altLang="ko-KR"/>
+              <a:t>Task Master </a:t>
+            </a:r>
+            <a:r>
+              <a:rPr lang="ko-KR" altLang="en-US"/>
+              <a:t>작업 복잡도 분석</a:t>
+            </a:r>
+          </a:p>
+        </p:txBody>
+      </p:sp>
+      <p:sp>
+        <p:nvSpPr>
+          <p:cNvPr id="3" name="TextBox 2">
+            <a:extLst>
+              <a:ext uri="{FF2B5EF4-FFF2-40B4-BE49-F238E27FC236}">
+                <a16:creationId xmlns:a16="http://schemas.microsoft.com/office/drawing/2014/main" id="{A5803EBE-CD2A-BAD3-77F3-27C8E090D5F1}"/>
+              </a:ext>
+            </a:extLst>
+          </p:cNvPr>
+          <p:cNvSpPr txBox="1"/>
+          <p:nvPr/>
+        </p:nvSpPr>
+        <p:spPr>
+          <a:xfrm>
+            <a:off x="6454701" y="1855865"/>
+            <a:ext cx="4836048" cy="830997"/>
+          </a:xfrm>
+          <a:prstGeom prst="rect">
+            <a:avLst/>
+          </a:prstGeom>
+          <a:noFill/>
+        </p:spPr>
+        <p:txBody>
+          <a:bodyPr wrap="square" rtlCol="0">
+            <a:spAutoFit/>
+          </a:bodyPr>
+          <a:lstStyle/>
+          <a:p>
+            <a:r>
+              <a:rPr lang="en-US" altLang="ko-KR" sz="1200">
+                <a:solidFill>
+                  <a:srgbClr val="FF0000"/>
+                </a:solidFill>
+              </a:rPr>
+              <a:t>@.taskmaster</a:t>
+            </a:r>
+            <a:r>
+              <a:rPr lang="ko-KR" altLang="en-US" sz="1200">
+                <a:solidFill>
+                  <a:srgbClr val="FF0000"/>
+                </a:solidFill>
+              </a:rPr>
+              <a:t> </a:t>
+            </a:r>
+            <a:r>
+              <a:rPr lang="en-US" altLang="ko-KR" sz="1200">
+                <a:solidFill>
+                  <a:srgbClr val="0000FF"/>
+                </a:solidFill>
+              </a:rPr>
+              <a:t>tm analyze-complexity</a:t>
+            </a:r>
+          </a:p>
+          <a:p>
+            <a:r>
+              <a:rPr lang="en-US" altLang="ko-KR" sz="1200">
+                <a:sym typeface="Wingdings" panose="05000000000000000000" pitchFamily="2" charset="2"/>
+              </a:rPr>
+              <a:t> </a:t>
+            </a:r>
+            <a:r>
+              <a:rPr lang="ko-KR" altLang="en-US" sz="1200">
+                <a:sym typeface="Wingdings" panose="05000000000000000000" pitchFamily="2" charset="2"/>
+              </a:rPr>
+              <a:t>해당 명령으로 작업 복잡도를 확인할 수 있다</a:t>
+            </a:r>
+            <a:r>
+              <a:rPr lang="en-US" altLang="ko-KR" sz="1200">
+                <a:sym typeface="Wingdings" panose="05000000000000000000" pitchFamily="2" charset="2"/>
+              </a:rPr>
+              <a:t>.</a:t>
+            </a:r>
+            <a:br>
+              <a:rPr lang="en-US" altLang="ko-KR" sz="1200">
+                <a:sym typeface="Wingdings" panose="05000000000000000000" pitchFamily="2" charset="2"/>
+              </a:rPr>
+            </a:br>
+            <a:br>
+              <a:rPr lang="en-US" altLang="ko-KR" sz="1200">
+                <a:sym typeface="Wingdings" panose="05000000000000000000" pitchFamily="2" charset="2"/>
+              </a:rPr>
+            </a:br>
+            <a:r>
+              <a:rPr lang="en-US" altLang="ko-KR" sz="1200">
+                <a:sym typeface="Wingdings" panose="05000000000000000000" pitchFamily="2" charset="2"/>
+              </a:rPr>
+              <a:t>※ </a:t>
+            </a:r>
+            <a:r>
+              <a:rPr lang="ko-KR" altLang="en-US" sz="1200">
+                <a:sym typeface="Wingdings" panose="05000000000000000000" pitchFamily="2" charset="2"/>
+              </a:rPr>
+              <a:t>복잡도 뿐만아니라 설명까지 확인하고 싶으면 </a:t>
+            </a:r>
+            <a:r>
+              <a:rPr lang="en-US" altLang="ko-KR" sz="1200">
+                <a:sym typeface="Wingdings" panose="05000000000000000000" pitchFamily="2" charset="2"/>
+              </a:rPr>
+              <a:t>complexity-report</a:t>
+            </a:r>
+            <a:endParaRPr lang="ko-KR" altLang="en-US" sz="1200"/>
+          </a:p>
+        </p:txBody>
+      </p:sp>
+      <p:pic>
+        <p:nvPicPr>
+          <p:cNvPr id="5" name="그림 4">
+            <a:extLst>
+              <a:ext uri="{FF2B5EF4-FFF2-40B4-BE49-F238E27FC236}">
+                <a16:creationId xmlns:a16="http://schemas.microsoft.com/office/drawing/2014/main" id="{DA5BF12D-5ED6-8661-C931-67C21859DC45}"/>
+              </a:ext>
+            </a:extLst>
+          </p:cNvPr>
+          <p:cNvPicPr>
+            <a:picLocks noChangeAspect="1"/>
+          </p:cNvPicPr>
+          <p:nvPr/>
+        </p:nvPicPr>
+        <p:blipFill>
+          <a:blip r:embed="rId2"/>
+          <a:stretch>
+            <a:fillRect/>
+          </a:stretch>
+        </p:blipFill>
+        <p:spPr>
+          <a:xfrm>
+            <a:off x="1221860" y="1855865"/>
+            <a:ext cx="5053845" cy="4328120"/>
+          </a:xfrm>
+          <a:prstGeom prst="rect">
+            <a:avLst/>
+          </a:prstGeom>
+        </p:spPr>
+      </p:pic>
+      <p:pic>
+        <p:nvPicPr>
+          <p:cNvPr id="7" name="그림 6">
+            <a:extLst>
+              <a:ext uri="{FF2B5EF4-FFF2-40B4-BE49-F238E27FC236}">
+                <a16:creationId xmlns:a16="http://schemas.microsoft.com/office/drawing/2014/main" id="{862CF3F9-4130-18E8-75AC-8DCB90492BFE}"/>
+              </a:ext>
+            </a:extLst>
+          </p:cNvPr>
+          <p:cNvPicPr>
+            <a:picLocks noChangeAspect="1"/>
+          </p:cNvPicPr>
+          <p:nvPr/>
+        </p:nvPicPr>
+        <p:blipFill>
+          <a:blip r:embed="rId3"/>
+          <a:stretch>
+            <a:fillRect/>
+          </a:stretch>
+        </p:blipFill>
+        <p:spPr>
+          <a:xfrm>
+            <a:off x="6454701" y="3227130"/>
+            <a:ext cx="4836048" cy="792795"/>
+          </a:xfrm>
+          <a:prstGeom prst="rect">
+            <a:avLst/>
+          </a:prstGeom>
+        </p:spPr>
+      </p:pic>
+    </p:spTree>
+    <p:extLst>
+      <p:ext uri="{BB962C8B-B14F-4D97-AF65-F5344CB8AC3E}">
+        <p14:creationId xmlns:p14="http://schemas.microsoft.com/office/powerpoint/2010/main" val="3617273341"/>
+      </p:ext>
+    </p:extLst>
+  </p:cSld>
+  <p:clrMapOvr>
+    <a:masterClrMapping/>
+  </p:clrMapOvr>
+</p:sld>
+</file>
+
+<file path=ppt/slides/slide17.xml><?xml version="1.0" encoding="utf-8"?>
+<p:sld xmlns:a="http://schemas.openxmlformats.org/drawingml/2006/main" xmlns:r="http://schemas.openxmlformats.org/officeDocument/2006/relationships" xmlns:p="http://schemas.openxmlformats.org/presentationml/2006/main">
+  <p:cSld>
+    <p:spTree>
+      <p:nvGrpSpPr>
+        <p:cNvPr id="1" name=""/>
+        <p:cNvGrpSpPr/>
+        <p:nvPr/>
+      </p:nvGrpSpPr>
+      <p:grpSpPr>
+        <a:xfrm>
+          <a:off x="0" y="0"/>
+          <a:ext cx="0" cy="0"/>
+          <a:chOff x="0" y="0"/>
+          <a:chExt cx="0" cy="0"/>
+        </a:xfrm>
+      </p:grpSpPr>
+      <p:sp>
+        <p:nvSpPr>
+          <p:cNvPr id="2" name="제목 1">
+            <a:extLst>
+              <a:ext uri="{FF2B5EF4-FFF2-40B4-BE49-F238E27FC236}">
+                <a16:creationId xmlns:a16="http://schemas.microsoft.com/office/drawing/2014/main" id="{3547D64A-F121-6291-9667-753CDE969435}"/>
+              </a:ext>
+            </a:extLst>
+          </p:cNvPr>
+          <p:cNvSpPr>
+            <a:spLocks noGrp="1"/>
+          </p:cNvSpPr>
+          <p:nvPr>
+            <p:ph type="title"/>
+          </p:nvPr>
+        </p:nvSpPr>
+        <p:spPr/>
+        <p:txBody>
+          <a:bodyPr/>
+          <a:lstStyle/>
+          <a:p>
+            <a:r>
+              <a:rPr lang="en-US" altLang="ko-KR"/>
+              <a:t>Task Master Task </a:t>
+            </a:r>
+            <a:r>
+              <a:rPr lang="ko-KR" altLang="en-US"/>
+              <a:t>나누기</a:t>
+            </a:r>
+          </a:p>
+        </p:txBody>
+      </p:sp>
+      <p:pic>
+        <p:nvPicPr>
+          <p:cNvPr id="4" name="그림 3">
+            <a:extLst>
+              <a:ext uri="{FF2B5EF4-FFF2-40B4-BE49-F238E27FC236}">
+                <a16:creationId xmlns:a16="http://schemas.microsoft.com/office/drawing/2014/main" id="{98A3FE8A-D705-2821-8CED-7BA7B8F570EE}"/>
+              </a:ext>
+            </a:extLst>
+          </p:cNvPr>
+          <p:cNvPicPr>
+            <a:picLocks noChangeAspect="1"/>
+          </p:cNvPicPr>
+          <p:nvPr/>
+        </p:nvPicPr>
+        <p:blipFill>
+          <a:blip r:embed="rId2"/>
+          <a:stretch>
+            <a:fillRect/>
+          </a:stretch>
+        </p:blipFill>
+        <p:spPr>
+          <a:xfrm>
+            <a:off x="188864" y="1903820"/>
+            <a:ext cx="5752411" cy="1254159"/>
+          </a:xfrm>
+          <a:prstGeom prst="rect">
+            <a:avLst/>
+          </a:prstGeom>
+        </p:spPr>
+      </p:pic>
+      <p:sp>
+        <p:nvSpPr>
+          <p:cNvPr id="5" name="TextBox 4">
+            <a:extLst>
+              <a:ext uri="{FF2B5EF4-FFF2-40B4-BE49-F238E27FC236}">
+                <a16:creationId xmlns:a16="http://schemas.microsoft.com/office/drawing/2014/main" id="{225888AB-A155-9F51-4A6F-1EDB23DBFEB0}"/>
+              </a:ext>
+            </a:extLst>
+          </p:cNvPr>
+          <p:cNvSpPr txBox="1"/>
+          <p:nvPr/>
+        </p:nvSpPr>
+        <p:spPr>
+          <a:xfrm>
+            <a:off x="6096000" y="1903820"/>
+            <a:ext cx="5404701" cy="430887"/>
+          </a:xfrm>
+          <a:prstGeom prst="rect">
+            <a:avLst/>
+          </a:prstGeom>
+          <a:noFill/>
+        </p:spPr>
+        <p:txBody>
+          <a:bodyPr wrap="square" rtlCol="0">
+            <a:spAutoFit/>
+          </a:bodyPr>
+          <a:lstStyle/>
+          <a:p>
+            <a:r>
+              <a:rPr lang="en-US" altLang="ko-KR" sz="1100"/>
+              <a:t>@.taskmaster tm expand –all </a:t>
+            </a:r>
+            <a:r>
+              <a:rPr lang="en-US" altLang="ko-KR" sz="1100">
+                <a:sym typeface="Wingdings" panose="05000000000000000000" pitchFamily="2" charset="2"/>
+              </a:rPr>
+              <a:t> </a:t>
+            </a:r>
+            <a:r>
+              <a:rPr lang="ko-KR" altLang="en-US" sz="1100">
+                <a:sym typeface="Wingdings" panose="05000000000000000000" pitchFamily="2" charset="2"/>
+              </a:rPr>
+              <a:t>모든 작업에 대하여 복잡도 순으로 세부 작업으로 쪼갬</a:t>
+            </a:r>
+            <a:br>
+              <a:rPr lang="en-US" altLang="ko-KR" sz="1100">
+                <a:sym typeface="Wingdings" panose="05000000000000000000" pitchFamily="2" charset="2"/>
+              </a:rPr>
+            </a:br>
+            <a:r>
+              <a:rPr lang="en-US" altLang="ko-KR" sz="1100">
+                <a:sym typeface="Wingdings" panose="05000000000000000000" pitchFamily="2" charset="2"/>
+              </a:rPr>
+              <a:t>@.taskmaster</a:t>
+            </a:r>
+            <a:r>
+              <a:rPr lang="ko-KR" altLang="en-US" sz="1100">
+                <a:sym typeface="Wingdings" panose="05000000000000000000" pitchFamily="2" charset="2"/>
+              </a:rPr>
+              <a:t> </a:t>
+            </a:r>
+            <a:r>
+              <a:rPr lang="en-US" altLang="ko-KR" sz="1100">
+                <a:sym typeface="Wingdings" panose="05000000000000000000" pitchFamily="2" charset="2"/>
+              </a:rPr>
+              <a:t>tm</a:t>
+            </a:r>
+            <a:r>
+              <a:rPr lang="ko-KR" altLang="en-US" sz="1100">
+                <a:sym typeface="Wingdings" panose="05000000000000000000" pitchFamily="2" charset="2"/>
+              </a:rPr>
+              <a:t> </a:t>
+            </a:r>
+            <a:r>
+              <a:rPr lang="en-US" altLang="ko-KR" sz="1100">
+                <a:sym typeface="Wingdings" panose="05000000000000000000" pitchFamily="2" charset="2"/>
+              </a:rPr>
+              <a:t>expand</a:t>
+            </a:r>
+            <a:r>
+              <a:rPr lang="ko-KR" altLang="en-US" sz="1100">
+                <a:sym typeface="Wingdings" panose="05000000000000000000" pitchFamily="2" charset="2"/>
+              </a:rPr>
+              <a:t> </a:t>
+            </a:r>
+            <a:r>
+              <a:rPr lang="en-US" altLang="ko-KR" sz="1100">
+                <a:sym typeface="Wingdings" panose="05000000000000000000" pitchFamily="2" charset="2"/>
+              </a:rPr>
+              <a:t>--id = &lt;id&gt;  </a:t>
+            </a:r>
+            <a:r>
+              <a:rPr lang="ko-KR" altLang="en-US" sz="1100">
+                <a:sym typeface="Wingdings" panose="05000000000000000000" pitchFamily="2" charset="2"/>
+              </a:rPr>
+              <a:t>특정 작업을 세부 작업으로 나눔</a:t>
+            </a:r>
+            <a:r>
+              <a:rPr lang="en-US" altLang="ko-KR" sz="1100">
+                <a:sym typeface="Wingdings" panose="05000000000000000000" pitchFamily="2" charset="2"/>
+              </a:rPr>
+              <a:t>.</a:t>
+            </a:r>
+            <a:r>
+              <a:rPr lang="ko-KR" altLang="en-US" sz="1100">
+                <a:sym typeface="Wingdings" panose="05000000000000000000" pitchFamily="2" charset="2"/>
+              </a:rPr>
+              <a:t> </a:t>
+            </a:r>
+            <a:endParaRPr lang="ko-KR" altLang="en-US" sz="1100"/>
+          </a:p>
+        </p:txBody>
+      </p:sp>
+    </p:spTree>
+    <p:extLst>
+      <p:ext uri="{BB962C8B-B14F-4D97-AF65-F5344CB8AC3E}">
+        <p14:creationId xmlns:p14="http://schemas.microsoft.com/office/powerpoint/2010/main" val="4094347609"/>
+      </p:ext>
+    </p:extLst>
+  </p:cSld>
+  <p:clrMapOvr>
+    <a:masterClrMapping/>
+  </p:clrMapOvr>
+</p:sld>
+</file>
+
+<file path=ppt/slides/slide18.xml><?xml version="1.0" encoding="utf-8"?>
+<p:sld xmlns:a="http://schemas.openxmlformats.org/drawingml/2006/main" xmlns:r="http://schemas.openxmlformats.org/officeDocument/2006/relationships" xmlns:p="http://schemas.openxmlformats.org/presentationml/2006/main">
+  <p:cSld>
+    <p:spTree>
+      <p:nvGrpSpPr>
+        <p:cNvPr id="1" name=""/>
+        <p:cNvGrpSpPr/>
+        <p:nvPr/>
+      </p:nvGrpSpPr>
+      <p:grpSpPr>
+        <a:xfrm>
+          <a:off x="0" y="0"/>
+          <a:ext cx="0" cy="0"/>
+          <a:chOff x="0" y="0"/>
+          <a:chExt cx="0" cy="0"/>
+        </a:xfrm>
+      </p:grpSpPr>
+      <p:sp>
+        <p:nvSpPr>
+          <p:cNvPr id="2" name="제목 1">
+            <a:extLst>
+              <a:ext uri="{FF2B5EF4-FFF2-40B4-BE49-F238E27FC236}">
+                <a16:creationId xmlns:a16="http://schemas.microsoft.com/office/drawing/2014/main" id="{E3E1B4A0-DD6F-2C19-66F3-05DB578BC50A}"/>
+              </a:ext>
+            </a:extLst>
+          </p:cNvPr>
+          <p:cNvSpPr>
+            <a:spLocks noGrp="1"/>
+          </p:cNvSpPr>
+          <p:nvPr>
+            <p:ph type="title"/>
+          </p:nvPr>
+        </p:nvSpPr>
+        <p:spPr/>
+        <p:txBody>
+          <a:bodyPr/>
+          <a:lstStyle/>
+          <a:p>
+            <a:r>
+              <a:rPr lang="en-US" altLang="ko-KR"/>
+              <a:t>Task Master </a:t>
+            </a:r>
+            <a:r>
+              <a:rPr lang="ko-KR" altLang="en-US"/>
+              <a:t>사용 </a:t>
+            </a:r>
+            <a:r>
+              <a:rPr lang="en-US" altLang="ko-KR"/>
+              <a:t>Work Flow</a:t>
+            </a:r>
+            <a:endParaRPr lang="ko-KR" altLang="en-US"/>
+          </a:p>
+        </p:txBody>
+      </p:sp>
+      <p:sp>
+        <p:nvSpPr>
+          <p:cNvPr id="3" name="TextBox 2">
+            <a:extLst>
+              <a:ext uri="{FF2B5EF4-FFF2-40B4-BE49-F238E27FC236}">
+                <a16:creationId xmlns:a16="http://schemas.microsoft.com/office/drawing/2014/main" id="{69E213DB-F3E5-F3FC-7DFD-63E7B8C8C5AB}"/>
+              </a:ext>
+            </a:extLst>
+          </p:cNvPr>
+          <p:cNvSpPr txBox="1"/>
+          <p:nvPr/>
+        </p:nvSpPr>
+        <p:spPr>
+          <a:xfrm>
+            <a:off x="1197204" y="1875934"/>
+            <a:ext cx="9958476" cy="646331"/>
+          </a:xfrm>
+          <a:prstGeom prst="rect">
+            <a:avLst/>
+          </a:prstGeom>
+          <a:noFill/>
+        </p:spPr>
+        <p:txBody>
+          <a:bodyPr wrap="square" rtlCol="0">
+            <a:spAutoFit/>
+          </a:bodyPr>
+          <a:lstStyle/>
+          <a:p>
+            <a:r>
+              <a:rPr lang="en-US" altLang="ko-KR" sz="1200">
+                <a:solidFill>
+                  <a:srgbClr val="0000FF"/>
+                </a:solidFill>
+              </a:rPr>
+              <a:t>tm status</a:t>
+            </a:r>
+            <a:r>
+              <a:rPr lang="en-US" altLang="ko-KR" sz="1200"/>
+              <a:t> [</a:t>
+            </a:r>
+            <a:r>
+              <a:rPr lang="ko-KR" altLang="en-US" sz="1200"/>
+              <a:t>작업 상태 확인</a:t>
+            </a:r>
+            <a:r>
+              <a:rPr lang="en-US" altLang="ko-KR" sz="1200"/>
+              <a:t>] -&gt; pending(</a:t>
+            </a:r>
+            <a:r>
+              <a:rPr lang="ko-KR" altLang="en-US" sz="1200"/>
+              <a:t>보류중</a:t>
+            </a:r>
+            <a:r>
+              <a:rPr lang="en-US" altLang="ko-KR" sz="1200"/>
+              <a:t>) , in-progress(</a:t>
+            </a:r>
+            <a:r>
+              <a:rPr lang="ko-KR" altLang="en-US" sz="1200"/>
+              <a:t>작업중</a:t>
+            </a:r>
+            <a:r>
+              <a:rPr lang="en-US" altLang="ko-KR" sz="1200"/>
+              <a:t>), done(</a:t>
+            </a:r>
+            <a:r>
+              <a:rPr lang="ko-KR" altLang="en-US" sz="1200"/>
+              <a:t>완료</a:t>
+            </a:r>
+            <a:r>
+              <a:rPr lang="en-US" altLang="ko-KR" sz="1200"/>
+              <a:t>), review(</a:t>
+            </a:r>
+            <a:r>
+              <a:rPr lang="ko-KR" altLang="en-US" sz="1200"/>
+              <a:t>검토</a:t>
+            </a:r>
+            <a:r>
+              <a:rPr lang="en-US" altLang="ko-KR" sz="1200"/>
+              <a:t>), deferred(</a:t>
+            </a:r>
+            <a:r>
+              <a:rPr lang="ko-KR" altLang="en-US" sz="1200"/>
+              <a:t>연기됨</a:t>
+            </a:r>
+            <a:r>
+              <a:rPr lang="en-US" altLang="ko-KR" sz="1200"/>
+              <a:t>), cancelled</a:t>
+            </a:r>
+            <a:r>
+              <a:rPr lang="ko-KR" altLang="en-US" sz="1200"/>
+              <a:t> </a:t>
+            </a:r>
+            <a:r>
+              <a:rPr lang="en-US" altLang="ko-KR" sz="1200"/>
+              <a:t>(</a:t>
+            </a:r>
+            <a:r>
+              <a:rPr lang="ko-KR" altLang="en-US" sz="1200"/>
+              <a:t>취소됨</a:t>
+            </a:r>
+            <a:r>
+              <a:rPr lang="en-US" altLang="ko-KR" sz="1200"/>
+              <a:t>)</a:t>
+            </a:r>
+          </a:p>
+          <a:p>
+            <a:endParaRPr lang="en-US" altLang="ko-KR" sz="1200"/>
+          </a:p>
+          <a:p>
+            <a:endParaRPr lang="ko-KR" altLang="en-US" sz="1200"/>
+          </a:p>
+        </p:txBody>
+      </p:sp>
+      <p:pic>
+        <p:nvPicPr>
+          <p:cNvPr id="5" name="그림 4">
+            <a:extLst>
+              <a:ext uri="{FF2B5EF4-FFF2-40B4-BE49-F238E27FC236}">
+                <a16:creationId xmlns:a16="http://schemas.microsoft.com/office/drawing/2014/main" id="{20D14E31-700B-C680-E60D-C63E83138F8A}"/>
+              </a:ext>
+            </a:extLst>
+          </p:cNvPr>
+          <p:cNvPicPr>
+            <a:picLocks noChangeAspect="1"/>
+          </p:cNvPicPr>
+          <p:nvPr/>
+        </p:nvPicPr>
+        <p:blipFill>
+          <a:blip r:embed="rId2"/>
+          <a:stretch>
+            <a:fillRect/>
+          </a:stretch>
+        </p:blipFill>
+        <p:spPr>
+          <a:xfrm>
+            <a:off x="1282045" y="3868422"/>
+            <a:ext cx="4105848" cy="1267002"/>
+          </a:xfrm>
+          <a:prstGeom prst="rect">
+            <a:avLst/>
+          </a:prstGeom>
+        </p:spPr>
+      </p:pic>
+      <p:sp>
+        <p:nvSpPr>
+          <p:cNvPr id="6" name="TextBox 5">
+            <a:extLst>
+              <a:ext uri="{FF2B5EF4-FFF2-40B4-BE49-F238E27FC236}">
+                <a16:creationId xmlns:a16="http://schemas.microsoft.com/office/drawing/2014/main" id="{434FAD82-D3BC-95FF-4029-6996A14222FE}"/>
+              </a:ext>
+            </a:extLst>
+          </p:cNvPr>
+          <p:cNvSpPr txBox="1"/>
+          <p:nvPr/>
+        </p:nvSpPr>
+        <p:spPr>
+          <a:xfrm>
+            <a:off x="1197204" y="2328421"/>
+            <a:ext cx="9797592" cy="1477328"/>
+          </a:xfrm>
+          <a:prstGeom prst="rect">
+            <a:avLst/>
+          </a:prstGeom>
+          <a:noFill/>
+        </p:spPr>
+        <p:txBody>
+          <a:bodyPr wrap="square" rtlCol="0">
+            <a:spAutoFit/>
+          </a:bodyPr>
+          <a:lstStyle/>
+          <a:p>
+            <a:pPr marL="342900" indent="-342900">
+              <a:buAutoNum type="arabicPeriod"/>
+            </a:pPr>
+            <a:r>
+              <a:rPr lang="en-US" altLang="ko-KR"/>
+              <a:t>PRD</a:t>
+            </a:r>
+            <a:r>
+              <a:rPr lang="ko-KR" altLang="en-US"/>
+              <a:t> 생성 </a:t>
+            </a:r>
+            <a:endParaRPr lang="en-US" altLang="ko-KR"/>
+          </a:p>
+          <a:p>
+            <a:pPr marL="342900" indent="-342900">
+              <a:buAutoNum type="arabicPeriod"/>
+            </a:pPr>
+            <a:r>
+              <a:rPr lang="en-US" altLang="ko-KR"/>
+              <a:t>PRD </a:t>
+            </a:r>
+            <a:r>
+              <a:rPr lang="ko-KR" altLang="en-US"/>
+              <a:t>검토</a:t>
+            </a:r>
+            <a:endParaRPr lang="en-US" altLang="ko-KR"/>
+          </a:p>
+          <a:p>
+            <a:pPr marL="342900" indent="-342900">
+              <a:buAutoNum type="arabicPeriod"/>
+            </a:pPr>
+            <a:r>
+              <a:rPr lang="en-US" altLang="ko-KR"/>
+              <a:t>PRD</a:t>
+            </a:r>
+            <a:r>
+              <a:rPr lang="ko-KR" altLang="en-US"/>
+              <a:t> 기반 </a:t>
+            </a:r>
+            <a:r>
+              <a:rPr lang="en-US" altLang="ko-KR"/>
+              <a:t>Task </a:t>
+            </a:r>
+            <a:r>
+              <a:rPr lang="ko-KR" altLang="en-US"/>
+              <a:t>생성</a:t>
+            </a:r>
+            <a:r>
+              <a:rPr lang="en-US" altLang="ko-KR"/>
+              <a:t> </a:t>
+            </a:r>
+          </a:p>
+          <a:p>
+            <a:pPr marL="342900" indent="-342900">
+              <a:buAutoNum type="arabicPeriod"/>
+            </a:pPr>
+            <a:r>
+              <a:rPr lang="ko-KR" altLang="en-US"/>
+              <a:t>작업 복잡도 </a:t>
+            </a:r>
+            <a:r>
+              <a:rPr lang="en-US" altLang="ko-KR"/>
+              <a:t>/ </a:t>
+            </a:r>
+            <a:r>
+              <a:rPr lang="ko-KR" altLang="en-US"/>
+              <a:t>세부 작업 필요 여부 확인</a:t>
+            </a:r>
+            <a:endParaRPr lang="en-US" altLang="ko-KR"/>
+          </a:p>
+          <a:p>
+            <a:pPr marL="342900" indent="-342900">
+              <a:buAutoNum type="arabicPeriod"/>
+            </a:pPr>
+            <a:r>
+              <a:rPr lang="ko-KR" altLang="en-US"/>
+              <a:t>작업 요청</a:t>
+            </a:r>
+          </a:p>
+        </p:txBody>
+      </p:sp>
+      <p:sp>
+        <p:nvSpPr>
+          <p:cNvPr id="7" name="TextBox 6">
+            <a:extLst>
+              <a:ext uri="{FF2B5EF4-FFF2-40B4-BE49-F238E27FC236}">
+                <a16:creationId xmlns:a16="http://schemas.microsoft.com/office/drawing/2014/main" id="{DF704200-4C28-07B3-CCEA-9FB475CE4A27}"/>
+              </a:ext>
+            </a:extLst>
+          </p:cNvPr>
+          <p:cNvSpPr txBox="1"/>
+          <p:nvPr/>
+        </p:nvSpPr>
+        <p:spPr>
+          <a:xfrm>
+            <a:off x="1282045" y="5198097"/>
+            <a:ext cx="4110087" cy="276999"/>
+          </a:xfrm>
+          <a:prstGeom prst="rect">
+            <a:avLst/>
+          </a:prstGeom>
+          <a:noFill/>
+        </p:spPr>
+        <p:txBody>
+          <a:bodyPr wrap="square" rtlCol="0">
+            <a:spAutoFit/>
+          </a:bodyPr>
+          <a:lstStyle/>
+          <a:p>
+            <a:r>
+              <a:rPr lang="en-US" altLang="ko-KR" sz="1200"/>
+              <a:t>※ </a:t>
+            </a:r>
+            <a:r>
+              <a:rPr lang="ko-KR" altLang="en-US" sz="1200"/>
+              <a:t>작업 요청 예</a:t>
+            </a:r>
+          </a:p>
+        </p:txBody>
+      </p:sp>
+    </p:spTree>
+    <p:extLst>
+      <p:ext uri="{BB962C8B-B14F-4D97-AF65-F5344CB8AC3E}">
+        <p14:creationId xmlns:p14="http://schemas.microsoft.com/office/powerpoint/2010/main" val="4287326412"/>
       </p:ext>
     </p:extLst>
   </p:cSld>
@@ -3914,11 +6514,11 @@
           <a:lstStyle/>
           <a:p>
             <a:r>
-              <a:rPr lang="en-US" altLang="ko-KR" dirty="0"/>
+              <a:rPr lang="en-US" altLang="ko-KR"/>
               <a:t>Task Master AI </a:t>
             </a:r>
             <a:r>
-              <a:rPr lang="ko-KR" altLang="en-US" dirty="0"/>
+              <a:rPr lang="ko-KR" altLang="en-US"/>
               <a:t>필요성</a:t>
             </a:r>
           </a:p>
@@ -3953,54 +6553,54 @@
           <a:lstStyle/>
           <a:p>
             <a:r>
-              <a:rPr lang="en-US" altLang="ko-KR" dirty="0"/>
+              <a:rPr lang="en-US" altLang="ko-KR"/>
               <a:t>1. AI </a:t>
             </a:r>
             <a:r>
-              <a:rPr lang="ko-KR" altLang="en-US" dirty="0" err="1"/>
+              <a:rPr lang="ko-KR" altLang="en-US" err="1"/>
               <a:t>개발시</a:t>
             </a:r>
             <a:r>
-              <a:rPr lang="ko-KR" altLang="en-US" dirty="0"/>
+              <a:rPr lang="ko-KR" altLang="en-US"/>
               <a:t> 갑자기 이상한 방향으로 개발하는 경우</a:t>
             </a:r>
             <a:r>
-              <a:rPr lang="en-US" altLang="ko-KR" dirty="0"/>
+              <a:rPr lang="en-US" altLang="ko-KR"/>
               <a:t>. </a:t>
             </a:r>
             <a:br>
-              <a:rPr lang="en-US" altLang="ko-KR" dirty="0"/>
+              <a:rPr lang="en-US" altLang="ko-KR"/>
             </a:br>
             <a:r>
-              <a:rPr lang="en-US" altLang="ko-KR" dirty="0"/>
+              <a:rPr lang="en-US" altLang="ko-KR"/>
               <a:t>2. </a:t>
             </a:r>
             <a:r>
-              <a:rPr lang="ko-KR" altLang="en-US" dirty="0"/>
+              <a:rPr lang="ko-KR" altLang="en-US"/>
               <a:t>개발했던 기능을 다시 개발하려는 경우</a:t>
             </a:r>
             <a:r>
-              <a:rPr lang="en-US" altLang="ko-KR" dirty="0"/>
+              <a:rPr lang="en-US" altLang="ko-KR"/>
               <a:t>.</a:t>
             </a:r>
             <a:br>
-              <a:rPr lang="en-US" altLang="ko-KR" dirty="0"/>
+              <a:rPr lang="en-US" altLang="ko-KR"/>
             </a:br>
             <a:r>
-              <a:rPr lang="en-US" altLang="ko-KR" dirty="0"/>
+              <a:rPr lang="en-US" altLang="ko-KR"/>
               <a:t>3. </a:t>
             </a:r>
             <a:r>
-              <a:rPr lang="ko-KR" altLang="en-US" dirty="0"/>
+              <a:rPr lang="ko-KR" altLang="en-US"/>
               <a:t>요청하지 않은 기능이지만 방대한 기능을 작성하는 경우</a:t>
             </a:r>
             <a:r>
-              <a:rPr lang="en-US" altLang="ko-KR" dirty="0"/>
+              <a:rPr lang="en-US" altLang="ko-KR"/>
               <a:t>.</a:t>
             </a:r>
           </a:p>
           <a:p>
-            <a:endParaRPr lang="ko-KR" altLang="en-US" dirty="0"/>
+            <a:endParaRPr lang="ko-KR" altLang="en-US"/>
           </a:p>
         </p:txBody>
       </p:sp>
@@ -4056,10 +6656,10 @@
           <a:lstStyle/>
           <a:p>
             <a:r>
-              <a:rPr lang="en-US" altLang="ko-KR" dirty="0"/>
+              <a:rPr lang="en-US" altLang="ko-KR"/>
               <a:t>Cli - Install </a:t>
             </a:r>
-            <a:endParaRPr lang="ko-KR" altLang="en-US" dirty="0"/>
+            <a:endParaRPr lang="ko-KR" altLang="en-US"/>
           </a:p>
         </p:txBody>
       </p:sp>
@@ -4127,252 +6727,252 @@
           <a:lstStyle/>
           <a:p>
             <a:r>
-              <a:rPr lang="ko-KR" altLang="en-US" dirty="0"/>
+              <a:rPr lang="ko-KR" altLang="en-US"/>
               <a:t># </a:t>
             </a:r>
             <a:r>
-              <a:rPr lang="ko-KR" altLang="en-US" dirty="0" err="1"/>
+              <a:rPr lang="ko-KR" altLang="en-US" err="1"/>
               <a:t>Install</a:t>
             </a:r>
             <a:r>
-              <a:rPr lang="ko-KR" altLang="en-US" dirty="0"/>
+              <a:rPr lang="ko-KR" altLang="en-US"/>
               <a:t> </a:t>
             </a:r>
             <a:r>
-              <a:rPr lang="ko-KR" altLang="en-US" dirty="0" err="1"/>
+              <a:rPr lang="ko-KR" altLang="en-US" err="1"/>
               <a:t>globally</a:t>
             </a:r>
-            <a:endParaRPr lang="ko-KR" altLang="en-US" dirty="0"/>
-          </a:p>
-          <a:p>
-            <a:r>
-              <a:rPr lang="ko-KR" altLang="en-US" sz="1200" dirty="0" err="1"/>
+            <a:endParaRPr lang="ko-KR" altLang="en-US"/>
+          </a:p>
+          <a:p>
+            <a:r>
+              <a:rPr lang="ko-KR" altLang="en-US" sz="1200" err="1"/>
               <a:t>npm</a:t>
             </a:r>
             <a:r>
-              <a:rPr lang="ko-KR" altLang="en-US" sz="1200" dirty="0"/>
+              <a:rPr lang="ko-KR" altLang="en-US" sz="1200"/>
               <a:t> </a:t>
             </a:r>
             <a:r>
-              <a:rPr lang="ko-KR" altLang="en-US" sz="1200" dirty="0" err="1"/>
+              <a:rPr lang="ko-KR" altLang="en-US" sz="1200" err="1"/>
               <a:t>install</a:t>
             </a:r>
             <a:r>
-              <a:rPr lang="ko-KR" altLang="en-US" sz="1200" dirty="0"/>
+              <a:rPr lang="ko-KR" altLang="en-US" sz="1200"/>
               <a:t> -</a:t>
             </a:r>
             <a:r>
-              <a:rPr lang="ko-KR" altLang="en-US" sz="1200" dirty="0" err="1"/>
+              <a:rPr lang="ko-KR" altLang="en-US" sz="1200" err="1"/>
               <a:t>g</a:t>
             </a:r>
             <a:r>
-              <a:rPr lang="ko-KR" altLang="en-US" sz="1200" dirty="0"/>
+              <a:rPr lang="ko-KR" altLang="en-US" sz="1200"/>
               <a:t> </a:t>
             </a:r>
             <a:r>
-              <a:rPr lang="ko-KR" altLang="en-US" sz="1200" dirty="0" err="1"/>
+              <a:rPr lang="ko-KR" altLang="en-US" sz="1200" err="1"/>
               <a:t>task-master-ai</a:t>
             </a:r>
-            <a:endParaRPr lang="ko-KR" altLang="en-US" sz="1200" dirty="0"/>
-          </a:p>
-          <a:p>
-            <a:endParaRPr lang="ko-KR" altLang="en-US" sz="1200" dirty="0"/>
-          </a:p>
-          <a:p>
-            <a:r>
-              <a:rPr lang="ko-KR" altLang="en-US" sz="1200" dirty="0"/>
+            <a:endParaRPr lang="ko-KR" altLang="en-US" sz="1200"/>
+          </a:p>
+          <a:p>
+            <a:endParaRPr lang="ko-KR" altLang="en-US" sz="1200"/>
+          </a:p>
+          <a:p>
+            <a:r>
+              <a:rPr lang="ko-KR" altLang="en-US" sz="1200"/>
               <a:t># OR </a:t>
             </a:r>
             <a:r>
-              <a:rPr lang="ko-KR" altLang="en-US" sz="1200" dirty="0" err="1"/>
+              <a:rPr lang="ko-KR" altLang="en-US" sz="1200" err="1"/>
               <a:t>install</a:t>
             </a:r>
             <a:r>
-              <a:rPr lang="ko-KR" altLang="en-US" sz="1200" dirty="0"/>
+              <a:rPr lang="ko-KR" altLang="en-US" sz="1200"/>
               <a:t> </a:t>
             </a:r>
             <a:r>
-              <a:rPr lang="ko-KR" altLang="en-US" sz="1200" dirty="0" err="1"/>
+              <a:rPr lang="ko-KR" altLang="en-US" sz="1200" err="1"/>
               <a:t>locally</a:t>
             </a:r>
             <a:r>
-              <a:rPr lang="ko-KR" altLang="en-US" sz="1200" dirty="0"/>
+              <a:rPr lang="ko-KR" altLang="en-US" sz="1200"/>
               <a:t> </a:t>
             </a:r>
             <a:r>
-              <a:rPr lang="ko-KR" altLang="en-US" sz="1200" dirty="0" err="1"/>
+              <a:rPr lang="ko-KR" altLang="en-US" sz="1200" err="1"/>
               <a:t>within</a:t>
             </a:r>
             <a:r>
-              <a:rPr lang="ko-KR" altLang="en-US" sz="1200" dirty="0"/>
+              <a:rPr lang="ko-KR" altLang="en-US" sz="1200"/>
               <a:t> </a:t>
             </a:r>
             <a:r>
-              <a:rPr lang="ko-KR" altLang="en-US" sz="1200" dirty="0" err="1"/>
+              <a:rPr lang="ko-KR" altLang="en-US" sz="1200" err="1"/>
               <a:t>your</a:t>
             </a:r>
             <a:r>
-              <a:rPr lang="ko-KR" altLang="en-US" sz="1200" dirty="0"/>
+              <a:rPr lang="ko-KR" altLang="en-US" sz="1200"/>
               <a:t> </a:t>
             </a:r>
             <a:r>
-              <a:rPr lang="ko-KR" altLang="en-US" sz="1200" dirty="0" err="1"/>
+              <a:rPr lang="ko-KR" altLang="en-US" sz="1200" err="1"/>
               <a:t>project</a:t>
             </a:r>
-            <a:endParaRPr lang="ko-KR" altLang="en-US" sz="1200" dirty="0"/>
-          </a:p>
-          <a:p>
-            <a:r>
-              <a:rPr lang="ko-KR" altLang="en-US" sz="1200" dirty="0" err="1"/>
+            <a:endParaRPr lang="ko-KR" altLang="en-US" sz="1200"/>
+          </a:p>
+          <a:p>
+            <a:r>
+              <a:rPr lang="ko-KR" altLang="en-US" sz="1200" err="1"/>
               <a:t>npm</a:t>
             </a:r>
             <a:r>
-              <a:rPr lang="ko-KR" altLang="en-US" sz="1200" dirty="0"/>
+              <a:rPr lang="ko-KR" altLang="en-US" sz="1200"/>
               <a:t> </a:t>
             </a:r>
             <a:r>
-              <a:rPr lang="ko-KR" altLang="en-US" sz="1200" dirty="0" err="1"/>
+              <a:rPr lang="ko-KR" altLang="en-US" sz="1200" err="1"/>
               <a:t>install</a:t>
             </a:r>
             <a:r>
-              <a:rPr lang="ko-KR" altLang="en-US" sz="1200" dirty="0"/>
+              <a:rPr lang="ko-KR" altLang="en-US" sz="1200"/>
               <a:t> </a:t>
             </a:r>
             <a:r>
-              <a:rPr lang="ko-KR" altLang="en-US" sz="1200" dirty="0" err="1"/>
+              <a:rPr lang="ko-KR" altLang="en-US" sz="1200" err="1"/>
               <a:t>task-master-ai</a:t>
             </a:r>
             <a:br>
-              <a:rPr lang="en-US" altLang="ko-KR" dirty="0"/>
+              <a:rPr lang="en-US" altLang="ko-KR"/>
             </a:br>
             <a:br>
-              <a:rPr lang="en-US" altLang="ko-KR" dirty="0"/>
+              <a:rPr lang="en-US" altLang="ko-KR"/>
             </a:br>
             <a:r>
-              <a:rPr lang="en-US" altLang="ko-KR" dirty="0"/>
+              <a:rPr lang="en-US" altLang="ko-KR"/>
               <a:t># Initialize a new project</a:t>
             </a:r>
             <a:br>
-              <a:rPr lang="en-US" altLang="ko-KR" dirty="0"/>
+              <a:rPr lang="en-US" altLang="ko-KR"/>
             </a:br>
             <a:r>
-              <a:rPr lang="en-US" altLang="ko-KR" sz="1200" dirty="0"/>
+              <a:rPr lang="en-US" altLang="ko-KR" sz="1200"/>
               <a:t># If installed globally</a:t>
             </a:r>
           </a:p>
           <a:p>
             <a:r>
-              <a:rPr lang="en-US" altLang="ko-KR" sz="1200" dirty="0"/>
+              <a:rPr lang="en-US" altLang="ko-KR" sz="1200"/>
               <a:t>task-master </a:t>
             </a:r>
             <a:r>
-              <a:rPr lang="en-US" altLang="ko-KR" sz="1200" dirty="0" err="1"/>
+              <a:rPr lang="en-US" altLang="ko-KR" sz="1200" err="1"/>
               <a:t>init</a:t>
             </a:r>
-            <a:endParaRPr lang="en-US" altLang="ko-KR" sz="1200" dirty="0"/>
-          </a:p>
-          <a:p>
-            <a:endParaRPr lang="en-US" altLang="ko-KR" sz="1200" dirty="0"/>
-          </a:p>
-          <a:p>
-            <a:r>
-              <a:rPr lang="en-US" altLang="ko-KR" sz="1200" dirty="0"/>
+            <a:endParaRPr lang="en-US" altLang="ko-KR" sz="1200"/>
+          </a:p>
+          <a:p>
+            <a:endParaRPr lang="en-US" altLang="ko-KR" sz="1200"/>
+          </a:p>
+          <a:p>
+            <a:r>
+              <a:rPr lang="en-US" altLang="ko-KR" sz="1200"/>
               <a:t># If installed locally</a:t>
             </a:r>
           </a:p>
           <a:p>
             <a:r>
-              <a:rPr lang="en-US" altLang="ko-KR" sz="1200" dirty="0" err="1"/>
+              <a:rPr lang="en-US" altLang="ko-KR" sz="1200" err="1"/>
               <a:t>npx</a:t>
             </a:r>
             <a:r>
-              <a:rPr lang="en-US" altLang="ko-KR" sz="1200" dirty="0"/>
+              <a:rPr lang="en-US" altLang="ko-KR" sz="1200"/>
               <a:t> task-master </a:t>
             </a:r>
             <a:r>
-              <a:rPr lang="en-US" altLang="ko-KR" sz="1200" dirty="0" err="1"/>
+              <a:rPr lang="en-US" altLang="ko-KR" sz="1200" err="1"/>
               <a:t>init</a:t>
             </a:r>
-            <a:endParaRPr lang="en-US" altLang="ko-KR" sz="1200" dirty="0"/>
-          </a:p>
-          <a:p>
-            <a:endParaRPr lang="en-US" altLang="ko-KR" sz="1200" dirty="0"/>
-          </a:p>
-          <a:p>
-            <a:r>
-              <a:rPr lang="en-US" altLang="ko-KR" sz="1200" dirty="0"/>
+            <a:endParaRPr lang="en-US" altLang="ko-KR" sz="1200"/>
+          </a:p>
+          <a:p>
+            <a:endParaRPr lang="en-US" altLang="ko-KR" sz="1200"/>
+          </a:p>
+          <a:p>
+            <a:r>
+              <a:rPr lang="en-US" altLang="ko-KR" sz="1200"/>
               <a:t># Initialize project with specific rules</a:t>
             </a:r>
           </a:p>
           <a:p>
             <a:r>
-              <a:rPr lang="en-US" altLang="ko-KR" sz="1200" dirty="0"/>
+              <a:rPr lang="en-US" altLang="ko-KR" sz="1200"/>
               <a:t>task-master </a:t>
             </a:r>
             <a:r>
-              <a:rPr lang="en-US" altLang="ko-KR" sz="1200" dirty="0" err="1"/>
+              <a:rPr lang="en-US" altLang="ko-KR" sz="1200" err="1"/>
               <a:t>init</a:t>
             </a:r>
             <a:r>
-              <a:rPr lang="en-US" altLang="ko-KR" sz="1200" dirty="0"/>
+              <a:rPr lang="en-US" altLang="ko-KR" sz="1200"/>
               <a:t> --rules </a:t>
             </a:r>
             <a:r>
-              <a:rPr lang="en-US" altLang="ko-KR" sz="1200" dirty="0" err="1"/>
+              <a:rPr lang="en-US" altLang="ko-KR" sz="1200" err="1"/>
               <a:t>cursor,windsurf,vscode</a:t>
             </a:r>
             <a:br>
-              <a:rPr lang="en-US" altLang="ko-KR" sz="1200" dirty="0"/>
+              <a:rPr lang="en-US" altLang="ko-KR" sz="1200"/>
             </a:br>
             <a:r>
-              <a:rPr lang="en-US" altLang="ko-KR" sz="1200" dirty="0">
+              <a:rPr lang="en-US" altLang="ko-KR" sz="1200">
                 <a:sym typeface="Wingdings" panose="05000000000000000000" pitchFamily="2" charset="2"/>
               </a:rPr>
               <a:t> </a:t>
             </a:r>
             <a:r>
-              <a:rPr lang="ko-KR" altLang="en-US" sz="1200" dirty="0">
+              <a:rPr lang="ko-KR" altLang="en-US" sz="1200">
                 <a:sym typeface="Wingdings" panose="05000000000000000000" pitchFamily="2" charset="2"/>
               </a:rPr>
               <a:t>설치는 </a:t>
             </a:r>
             <a:r>
-              <a:rPr lang="en-US" altLang="ko-KR" sz="1200" dirty="0">
+              <a:rPr lang="en-US" altLang="ko-KR" sz="1200">
                 <a:sym typeface="Wingdings" panose="05000000000000000000" pitchFamily="2" charset="2"/>
               </a:rPr>
               <a:t>cli </a:t>
             </a:r>
             <a:r>
-              <a:rPr lang="ko-KR" altLang="en-US" sz="1200" dirty="0">
+              <a:rPr lang="ko-KR" altLang="en-US" sz="1200">
                 <a:sym typeface="Wingdings" panose="05000000000000000000" pitchFamily="2" charset="2"/>
               </a:rPr>
               <a:t>글로벌로 실행은 </a:t>
             </a:r>
             <a:r>
-              <a:rPr lang="en-US" altLang="ko-KR" sz="1200" dirty="0">
+              <a:rPr lang="en-US" altLang="ko-KR" sz="1200">
                 <a:sym typeface="Wingdings" panose="05000000000000000000" pitchFamily="2" charset="2"/>
               </a:rPr>
               <a:t>Claude Code </a:t>
             </a:r>
             <a:r>
-              <a:rPr lang="ko-KR" altLang="en-US" sz="1200" dirty="0">
+              <a:rPr lang="ko-KR" altLang="en-US" sz="1200">
                 <a:sym typeface="Wingdings" panose="05000000000000000000" pitchFamily="2" charset="2"/>
               </a:rPr>
               <a:t>의 </a:t>
             </a:r>
             <a:r>
-              <a:rPr lang="en-US" altLang="ko-KR" sz="1200" dirty="0">
+              <a:rPr lang="en-US" altLang="ko-KR" sz="1200">
                 <a:sym typeface="Wingdings" panose="05000000000000000000" pitchFamily="2" charset="2"/>
               </a:rPr>
               <a:t>MCP</a:t>
             </a:r>
             <a:r>
-              <a:rPr lang="ko-KR" altLang="en-US" sz="1200" dirty="0">
+              <a:rPr lang="ko-KR" altLang="en-US" sz="1200">
                 <a:sym typeface="Wingdings" panose="05000000000000000000" pitchFamily="2" charset="2"/>
               </a:rPr>
               <a:t>로 진행</a:t>
             </a:r>
-            <a:endParaRPr lang="ko-KR" altLang="en-US" sz="1200" dirty="0"/>
+            <a:endParaRPr lang="ko-KR" altLang="en-US" sz="1200"/>
           </a:p>
         </p:txBody>
       </p:sp>
@@ -4458,18 +7058,18 @@
           <a:lstStyle/>
           <a:p>
             <a:r>
-              <a:rPr lang="en-US" altLang="ko-KR" dirty="0"/>
+              <a:rPr lang="en-US" altLang="ko-KR"/>
               <a:t>MCP</a:t>
             </a:r>
             <a:r>
-              <a:rPr lang="ko-KR" altLang="en-US" dirty="0"/>
+              <a:rPr lang="ko-KR" altLang="en-US"/>
               <a:t> </a:t>
             </a:r>
             <a:r>
-              <a:rPr lang="en-US" altLang="ko-KR" dirty="0"/>
+              <a:rPr lang="en-US" altLang="ko-KR"/>
               <a:t>– Install (1)</a:t>
             </a:r>
-            <a:endParaRPr lang="ko-KR" altLang="en-US" dirty="0"/>
+            <a:endParaRPr lang="ko-KR" altLang="en-US"/>
           </a:p>
         </p:txBody>
       </p:sp>
@@ -4601,18 +7201,447 @@
           <a:lstStyle/>
           <a:p>
             <a:r>
-              <a:rPr lang="en-US" altLang="ko-KR" dirty="0"/>
-              <a:t>MCP</a:t>
-            </a:r>
-            <a:r>
-              <a:rPr lang="ko-KR" altLang="en-US" dirty="0"/>
-              <a:t> </a:t>
-            </a:r>
-            <a:r>
-              <a:rPr lang="en-US" altLang="ko-KR" dirty="0"/>
-              <a:t>– Install (2) [IntelliJ]</a:t>
-            </a:r>
-            <a:endParaRPr lang="ko-KR" altLang="en-US" dirty="0"/>
+              <a:rPr lang="en-US" altLang="ko-KR"/>
+              <a:t>MCP – </a:t>
+            </a:r>
+            <a:r>
+              <a:rPr lang="ko-KR" altLang="en-US"/>
+              <a:t>복사 붙여넣기 </a:t>
+            </a:r>
+          </a:p>
+        </p:txBody>
+      </p:sp>
+      <p:sp>
+        <p:nvSpPr>
+          <p:cNvPr id="4" name="TextBox 3">
+            <a:extLst>
+              <a:ext uri="{FF2B5EF4-FFF2-40B4-BE49-F238E27FC236}">
+                <a16:creationId xmlns:a16="http://schemas.microsoft.com/office/drawing/2014/main" id="{CDC62277-F977-3D83-0DC4-76CFA225E02E}"/>
+              </a:ext>
+            </a:extLst>
+          </p:cNvPr>
+          <p:cNvSpPr txBox="1"/>
+          <p:nvPr/>
+        </p:nvSpPr>
+        <p:spPr>
+          <a:xfrm>
+            <a:off x="1199561" y="1950186"/>
+            <a:ext cx="6094428" cy="3785652"/>
+          </a:xfrm>
+          <a:prstGeom prst="rect">
+            <a:avLst/>
+          </a:prstGeom>
+          <a:noFill/>
+        </p:spPr>
+        <p:txBody>
+          <a:bodyPr wrap="square">
+            <a:spAutoFit/>
+          </a:bodyPr>
+          <a:lstStyle/>
+          <a:p>
+            <a:r>
+              <a:rPr lang="ko-KR" altLang="en-US" sz="1200"/>
+              <a:t>{</a:t>
+            </a:r>
+          </a:p>
+          <a:p>
+            <a:r>
+              <a:rPr lang="ko-KR" altLang="en-US" sz="1200"/>
+              <a:t>  "</a:t>
+            </a:r>
+            <a:r>
+              <a:rPr lang="ko-KR" altLang="en-US" sz="1200" err="1"/>
+              <a:t>mcpServers</a:t>
+            </a:r>
+            <a:r>
+              <a:rPr lang="ko-KR" altLang="en-US" sz="1200"/>
+              <a:t>": {</a:t>
+            </a:r>
+          </a:p>
+          <a:p>
+            <a:r>
+              <a:rPr lang="ko-KR" altLang="en-US" sz="1200"/>
+              <a:t>    "</a:t>
+            </a:r>
+            <a:r>
+              <a:rPr lang="ko-KR" altLang="en-US" sz="1200" err="1"/>
+              <a:t>taskmaster-ai</a:t>
+            </a:r>
+            <a:r>
+              <a:rPr lang="ko-KR" altLang="en-US" sz="1200"/>
+              <a:t>": {</a:t>
+            </a:r>
+          </a:p>
+          <a:p>
+            <a:r>
+              <a:rPr lang="ko-KR" altLang="en-US" sz="1200"/>
+              <a:t>      "</a:t>
+            </a:r>
+            <a:r>
+              <a:rPr lang="ko-KR" altLang="en-US" sz="1200" err="1"/>
+              <a:t>command</a:t>
+            </a:r>
+            <a:r>
+              <a:rPr lang="ko-KR" altLang="en-US" sz="1200"/>
+              <a:t>": "</a:t>
+            </a:r>
+            <a:r>
+              <a:rPr lang="ko-KR" altLang="en-US" sz="1200" err="1"/>
+              <a:t>npx</a:t>
+            </a:r>
+            <a:r>
+              <a:rPr lang="ko-KR" altLang="en-US" sz="1200"/>
+              <a:t>",</a:t>
+            </a:r>
+          </a:p>
+          <a:p>
+            <a:r>
+              <a:rPr lang="ko-KR" altLang="en-US" sz="1200"/>
+              <a:t>      "</a:t>
+            </a:r>
+            <a:r>
+              <a:rPr lang="ko-KR" altLang="en-US" sz="1200" err="1"/>
+              <a:t>args</a:t>
+            </a:r>
+            <a:r>
+              <a:rPr lang="ko-KR" altLang="en-US" sz="1200"/>
+              <a:t>": ["-</a:t>
+            </a:r>
+            <a:r>
+              <a:rPr lang="ko-KR" altLang="en-US" sz="1200" err="1"/>
+              <a:t>y</a:t>
+            </a:r>
+            <a:r>
+              <a:rPr lang="ko-KR" altLang="en-US" sz="1200"/>
+              <a:t>", "</a:t>
+            </a:r>
+            <a:r>
+              <a:rPr lang="ko-KR" altLang="en-US" sz="1200" err="1"/>
+              <a:t>task-master-ai</a:t>
+            </a:r>
+            <a:r>
+              <a:rPr lang="ko-KR" altLang="en-US" sz="1200"/>
+              <a:t>"],</a:t>
+            </a:r>
+          </a:p>
+          <a:p>
+            <a:r>
+              <a:rPr lang="ko-KR" altLang="en-US" sz="1200"/>
+              <a:t>      "</a:t>
+            </a:r>
+            <a:r>
+              <a:rPr lang="ko-KR" altLang="en-US" sz="1200" err="1"/>
+              <a:t>env</a:t>
+            </a:r>
+            <a:r>
+              <a:rPr lang="ko-KR" altLang="en-US" sz="1200"/>
+              <a:t>": {</a:t>
+            </a:r>
+          </a:p>
+          <a:p>
+            <a:r>
+              <a:rPr lang="ko-KR" altLang="en-US" sz="1200"/>
+              <a:t>        "ANTHROPIC_API_KEY": "YOUR_ANTHROPIC_API_KEY_HERE",</a:t>
+            </a:r>
+          </a:p>
+          <a:p>
+            <a:r>
+              <a:rPr lang="ko-KR" altLang="en-US" sz="1200"/>
+              <a:t>        "PERPLEXITY_API_KEY": "YOUR_PERPLEXITY_API_KEY_HERE",</a:t>
+            </a:r>
+          </a:p>
+          <a:p>
+            <a:r>
+              <a:rPr lang="ko-KR" altLang="en-US" sz="1200"/>
+              <a:t>        "OPENAI_API_KEY": "YOUR_OPENAI_KEY_HERE",</a:t>
+            </a:r>
+          </a:p>
+          <a:p>
+            <a:r>
+              <a:rPr lang="ko-KR" altLang="en-US" sz="1200"/>
+              <a:t>        "GOOGLE_API_KEY": "YOUR_GOOGLE_KEY_HERE",</a:t>
+            </a:r>
+          </a:p>
+          <a:p>
+            <a:r>
+              <a:rPr lang="ko-KR" altLang="en-US" sz="1200"/>
+              <a:t>        "MISTRAL_API_KEY": "YOUR_MISTRAL_KEY_HERE",</a:t>
+            </a:r>
+          </a:p>
+          <a:p>
+            <a:r>
+              <a:rPr lang="ko-KR" altLang="en-US" sz="1200"/>
+              <a:t>        "OPENROUTER_API_KEY": "YOUR_OPENROUTER_KEY_HERE",</a:t>
+            </a:r>
+          </a:p>
+          <a:p>
+            <a:r>
+              <a:rPr lang="ko-KR" altLang="en-US" sz="1200"/>
+              <a:t>        "XAI_API_KEY": "YOUR_XAI_KEY_HERE",</a:t>
+            </a:r>
+          </a:p>
+          <a:p>
+            <a:r>
+              <a:rPr lang="ko-KR" altLang="en-US" sz="1200"/>
+              <a:t>        "AZURE_OPENAI_API_KEY": "YOUR_AZURE_KEY_HERE",</a:t>
+            </a:r>
+          </a:p>
+          <a:p>
+            <a:r>
+              <a:rPr lang="ko-KR" altLang="en-US" sz="1200"/>
+              <a:t>        "OLLAMA_API_KEY": "YOUR_OLLAMA_API_KEY_HERE"</a:t>
+            </a:r>
+          </a:p>
+          <a:p>
+            <a:r>
+              <a:rPr lang="ko-KR" altLang="en-US" sz="1200"/>
+              <a:t>      }</a:t>
+            </a:r>
+          </a:p>
+          <a:p>
+            <a:r>
+              <a:rPr lang="ko-KR" altLang="en-US" sz="1200"/>
+              <a:t>    }</a:t>
+            </a:r>
+          </a:p>
+          <a:p>
+            <a:r>
+              <a:rPr lang="ko-KR" altLang="en-US" sz="1200"/>
+              <a:t>  }</a:t>
+            </a:r>
+          </a:p>
+          <a:p>
+            <a:r>
+              <a:rPr lang="ko-KR" altLang="en-US" sz="1200"/>
+              <a:t>}</a:t>
+            </a:r>
+            <a:br>
+              <a:rPr lang="en-US" altLang="ko-KR" sz="1200"/>
+            </a:br>
+            <a:endParaRPr lang="ko-KR" altLang="en-US" sz="1200"/>
+          </a:p>
+        </p:txBody>
+      </p:sp>
+      <p:sp>
+        <p:nvSpPr>
+          <p:cNvPr id="6" name="TextBox 5">
+            <a:extLst>
+              <a:ext uri="{FF2B5EF4-FFF2-40B4-BE49-F238E27FC236}">
+                <a16:creationId xmlns:a16="http://schemas.microsoft.com/office/drawing/2014/main" id="{0B7DDDFF-44C1-CA3C-1E32-3EFBDFB3338E}"/>
+              </a:ext>
+            </a:extLst>
+          </p:cNvPr>
+          <p:cNvSpPr txBox="1"/>
+          <p:nvPr/>
+        </p:nvSpPr>
+        <p:spPr>
+          <a:xfrm>
+            <a:off x="6007231" y="1950186"/>
+            <a:ext cx="6094428" cy="3600986"/>
+          </a:xfrm>
+          <a:prstGeom prst="rect">
+            <a:avLst/>
+          </a:prstGeom>
+          <a:noFill/>
+        </p:spPr>
+        <p:txBody>
+          <a:bodyPr wrap="square">
+            <a:spAutoFit/>
+          </a:bodyPr>
+          <a:lstStyle/>
+          <a:p>
+            <a:r>
+              <a:rPr lang="ko-KR" altLang="en-US" sz="1200"/>
+              <a:t>{</a:t>
+            </a:r>
+          </a:p>
+          <a:p>
+            <a:r>
+              <a:rPr lang="ko-KR" altLang="en-US" sz="1200"/>
+              <a:t>  "</a:t>
+            </a:r>
+            <a:r>
+              <a:rPr lang="ko-KR" altLang="en-US" sz="1200" err="1"/>
+              <a:t>servers</a:t>
+            </a:r>
+            <a:r>
+              <a:rPr lang="ko-KR" altLang="en-US" sz="1200"/>
+              <a:t>": {</a:t>
+            </a:r>
+          </a:p>
+          <a:p>
+            <a:r>
+              <a:rPr lang="ko-KR" altLang="en-US" sz="1200"/>
+              <a:t>    "</a:t>
+            </a:r>
+            <a:r>
+              <a:rPr lang="ko-KR" altLang="en-US" sz="1200" err="1"/>
+              <a:t>taskmaster-ai</a:t>
+            </a:r>
+            <a:r>
+              <a:rPr lang="ko-KR" altLang="en-US" sz="1200"/>
+              <a:t>": {</a:t>
+            </a:r>
+          </a:p>
+          <a:p>
+            <a:r>
+              <a:rPr lang="ko-KR" altLang="en-US" sz="1200"/>
+              <a:t>      "</a:t>
+            </a:r>
+            <a:r>
+              <a:rPr lang="ko-KR" altLang="en-US" sz="1200" err="1"/>
+              <a:t>command</a:t>
+            </a:r>
+            <a:r>
+              <a:rPr lang="ko-KR" altLang="en-US" sz="1200"/>
+              <a:t>": "</a:t>
+            </a:r>
+            <a:r>
+              <a:rPr lang="ko-KR" altLang="en-US" sz="1200" err="1"/>
+              <a:t>npx</a:t>
+            </a:r>
+            <a:r>
+              <a:rPr lang="ko-KR" altLang="en-US" sz="1200"/>
+              <a:t>",</a:t>
+            </a:r>
+          </a:p>
+          <a:p>
+            <a:r>
+              <a:rPr lang="ko-KR" altLang="en-US" sz="1200"/>
+              <a:t>      "</a:t>
+            </a:r>
+            <a:r>
+              <a:rPr lang="ko-KR" altLang="en-US" sz="1200" err="1"/>
+              <a:t>args</a:t>
+            </a:r>
+            <a:r>
+              <a:rPr lang="ko-KR" altLang="en-US" sz="1200"/>
+              <a:t>": ["-</a:t>
+            </a:r>
+            <a:r>
+              <a:rPr lang="ko-KR" altLang="en-US" sz="1200" err="1"/>
+              <a:t>y</a:t>
+            </a:r>
+            <a:r>
+              <a:rPr lang="ko-KR" altLang="en-US" sz="1200"/>
+              <a:t>", "</a:t>
+            </a:r>
+            <a:r>
+              <a:rPr lang="ko-KR" altLang="en-US" sz="1200" err="1"/>
+              <a:t>task-master-ai</a:t>
+            </a:r>
+            <a:r>
+              <a:rPr lang="ko-KR" altLang="en-US" sz="1200"/>
+              <a:t>"],</a:t>
+            </a:r>
+          </a:p>
+          <a:p>
+            <a:r>
+              <a:rPr lang="ko-KR" altLang="en-US" sz="1200"/>
+              <a:t>      "</a:t>
+            </a:r>
+            <a:r>
+              <a:rPr lang="ko-KR" altLang="en-US" sz="1200" err="1"/>
+              <a:t>env</a:t>
+            </a:r>
+            <a:r>
+              <a:rPr lang="ko-KR" altLang="en-US" sz="1200"/>
+              <a:t>": {</a:t>
+            </a:r>
+          </a:p>
+          <a:p>
+            <a:r>
+              <a:rPr lang="ko-KR" altLang="en-US" sz="1200"/>
+              <a:t>        "ANTHROPIC_API_KEY": "YOUR_ANTHROPIC_API_KEY_HERE",</a:t>
+            </a:r>
+          </a:p>
+          <a:p>
+            <a:r>
+              <a:rPr lang="ko-KR" altLang="en-US" sz="1200"/>
+              <a:t>        "PERPLEXITY_API_KEY": "YOUR_PERPLEXITY_API_KEY_HERE",</a:t>
+            </a:r>
+          </a:p>
+          <a:p>
+            <a:r>
+              <a:rPr lang="ko-KR" altLang="en-US" sz="1200"/>
+              <a:t>        "OPENAI_API_KEY": "YOUR_OPENAI_KEY_HERE",</a:t>
+            </a:r>
+          </a:p>
+          <a:p>
+            <a:r>
+              <a:rPr lang="ko-KR" altLang="en-US" sz="1200"/>
+              <a:t>        "GOOGLE_API_KEY": "YOUR_GOOGLE_KEY_HERE",</a:t>
+            </a:r>
+          </a:p>
+          <a:p>
+            <a:r>
+              <a:rPr lang="ko-KR" altLang="en-US" sz="1200"/>
+              <a:t>        "MISTRAL_API_KEY": "YOUR_MISTRAL_KEY_HERE",</a:t>
+            </a:r>
+          </a:p>
+          <a:p>
+            <a:r>
+              <a:rPr lang="ko-KR" altLang="en-US" sz="1200"/>
+              <a:t>        "OPENROUTER_API_KEY": "YOUR_OPENROUTER_KEY_HERE",</a:t>
+            </a:r>
+          </a:p>
+          <a:p>
+            <a:r>
+              <a:rPr lang="ko-KR" altLang="en-US" sz="1200"/>
+              <a:t>        "XAI_API_KEY": "YOUR_XAI_KEY_HERE",</a:t>
+            </a:r>
+          </a:p>
+          <a:p>
+            <a:r>
+              <a:rPr lang="ko-KR" altLang="en-US" sz="1200"/>
+              <a:t>        "AZURE_OPENAI_API_KEY": "YOUR_AZURE_KEY_HERE"</a:t>
+            </a:r>
+          </a:p>
+          <a:p>
+            <a:r>
+              <a:rPr lang="ko-KR" altLang="en-US" sz="1200"/>
+              <a:t>      },</a:t>
+            </a:r>
+          </a:p>
+          <a:p>
+            <a:r>
+              <a:rPr lang="ko-KR" altLang="en-US" sz="1200"/>
+              <a:t>      "</a:t>
+            </a:r>
+            <a:r>
+              <a:rPr lang="ko-KR" altLang="en-US" sz="1200" err="1"/>
+              <a:t>type</a:t>
+            </a:r>
+            <a:r>
+              <a:rPr lang="ko-KR" altLang="en-US" sz="1200"/>
+              <a:t>": "</a:t>
+            </a:r>
+            <a:r>
+              <a:rPr lang="ko-KR" altLang="en-US" sz="1200" err="1"/>
+              <a:t>stdio</a:t>
+            </a:r>
+            <a:r>
+              <a:rPr lang="ko-KR" altLang="en-US" sz="1200"/>
+              <a:t>"</a:t>
+            </a:r>
+          </a:p>
+          <a:p>
+            <a:r>
+              <a:rPr lang="ko-KR" altLang="en-US" sz="1200"/>
+              <a:t>    }</a:t>
+            </a:r>
+          </a:p>
+          <a:p>
+            <a:r>
+              <a:rPr lang="ko-KR" altLang="en-US" sz="1200"/>
+              <a:t>  }</a:t>
+            </a:r>
+          </a:p>
+          <a:p>
+            <a:r>
+              <a:rPr lang="ko-KR" altLang="en-US" sz="1200"/>
+              <a:t>}</a:t>
+            </a:r>
           </a:p>
         </p:txBody>
       </p:sp>
@@ -4620,6 +7649,1081 @@
     <p:extLst>
       <p:ext uri="{BB962C8B-B14F-4D97-AF65-F5344CB8AC3E}">
         <p14:creationId xmlns:p14="http://schemas.microsoft.com/office/powerpoint/2010/main" val="2460944933"/>
+      </p:ext>
+    </p:extLst>
+  </p:cSld>
+  <p:clrMapOvr>
+    <a:masterClrMapping/>
+  </p:clrMapOvr>
+</p:sld>
+</file>
+
+<file path=ppt/slides/slide6.xml><?xml version="1.0" encoding="utf-8"?>
+<p:sld xmlns:a="http://schemas.openxmlformats.org/drawingml/2006/main" xmlns:r="http://schemas.openxmlformats.org/officeDocument/2006/relationships" xmlns:p="http://schemas.openxmlformats.org/presentationml/2006/main">
+  <p:cSld>
+    <p:spTree>
+      <p:nvGrpSpPr>
+        <p:cNvPr id="1" name=""/>
+        <p:cNvGrpSpPr/>
+        <p:nvPr/>
+      </p:nvGrpSpPr>
+      <p:grpSpPr>
+        <a:xfrm>
+          <a:off x="0" y="0"/>
+          <a:ext cx="0" cy="0"/>
+          <a:chOff x="0" y="0"/>
+          <a:chExt cx="0" cy="0"/>
+        </a:xfrm>
+      </p:grpSpPr>
+      <p:sp>
+        <p:nvSpPr>
+          <p:cNvPr id="2" name="제목 1">
+            <a:extLst>
+              <a:ext uri="{FF2B5EF4-FFF2-40B4-BE49-F238E27FC236}">
+                <a16:creationId xmlns:a16="http://schemas.microsoft.com/office/drawing/2014/main" id="{1E10FC65-D810-F796-B6A6-1DE780ABA5FC}"/>
+              </a:ext>
+            </a:extLst>
+          </p:cNvPr>
+          <p:cNvSpPr>
+            <a:spLocks noGrp="1"/>
+          </p:cNvSpPr>
+          <p:nvPr>
+            <p:ph type="title"/>
+          </p:nvPr>
+        </p:nvSpPr>
+        <p:spPr/>
+        <p:txBody>
+          <a:bodyPr/>
+          <a:lstStyle/>
+          <a:p>
+            <a:r>
+              <a:rPr lang="en-US" altLang="ko-KR"/>
+              <a:t>MCP</a:t>
+            </a:r>
+            <a:r>
+              <a:rPr lang="ko-KR" altLang="en-US"/>
+              <a:t> </a:t>
+            </a:r>
+            <a:r>
+              <a:rPr lang="en-US" altLang="ko-KR"/>
+              <a:t>– Install (2)  [.</a:t>
+            </a:r>
+            <a:r>
+              <a:rPr lang="en-US" altLang="ko-KR" err="1"/>
+              <a:t>mcp.json</a:t>
+            </a:r>
+            <a:r>
+              <a:rPr lang="ko-KR" altLang="en-US"/>
+              <a:t>설정</a:t>
+            </a:r>
+            <a:r>
+              <a:rPr lang="en-US" altLang="ko-KR"/>
+              <a:t>]</a:t>
+            </a:r>
+            <a:endParaRPr lang="ko-KR" altLang="en-US"/>
+          </a:p>
+        </p:txBody>
+      </p:sp>
+      <p:pic>
+        <p:nvPicPr>
+          <p:cNvPr id="4" name="그림 3">
+            <a:extLst>
+              <a:ext uri="{FF2B5EF4-FFF2-40B4-BE49-F238E27FC236}">
+                <a16:creationId xmlns:a16="http://schemas.microsoft.com/office/drawing/2014/main" id="{40AEE45B-A0D0-C82F-5671-E0A575CDB4A9}"/>
+              </a:ext>
+            </a:extLst>
+          </p:cNvPr>
+          <p:cNvPicPr>
+            <a:picLocks noChangeAspect="1"/>
+          </p:cNvPicPr>
+          <p:nvPr/>
+        </p:nvPicPr>
+        <p:blipFill>
+          <a:blip r:embed="rId2"/>
+          <a:stretch>
+            <a:fillRect/>
+          </a:stretch>
+        </p:blipFill>
+        <p:spPr>
+          <a:xfrm>
+            <a:off x="446830" y="1910560"/>
+            <a:ext cx="3848637" cy="1943371"/>
+          </a:xfrm>
+          <a:prstGeom prst="rect">
+            <a:avLst/>
+          </a:prstGeom>
+        </p:spPr>
+      </p:pic>
+      <p:grpSp>
+        <p:nvGrpSpPr>
+          <p:cNvPr id="12" name="그룹 11">
+            <a:extLst>
+              <a:ext uri="{FF2B5EF4-FFF2-40B4-BE49-F238E27FC236}">
+                <a16:creationId xmlns:a16="http://schemas.microsoft.com/office/drawing/2014/main" id="{E22C822F-3DA5-A663-95E2-52BEECDF5C32}"/>
+              </a:ext>
+            </a:extLst>
+          </p:cNvPr>
+          <p:cNvGrpSpPr/>
+          <p:nvPr/>
+        </p:nvGrpSpPr>
+        <p:grpSpPr>
+          <a:xfrm>
+            <a:off x="4575059" y="1910560"/>
+            <a:ext cx="7397752" cy="2536581"/>
+            <a:chOff x="4575059" y="1910560"/>
+            <a:chExt cx="7397752" cy="2536581"/>
+          </a:xfrm>
+        </p:grpSpPr>
+        <p:grpSp>
+          <p:nvGrpSpPr>
+            <p:cNvPr id="8" name="그룹 7">
+              <a:extLst>
+                <a:ext uri="{FF2B5EF4-FFF2-40B4-BE49-F238E27FC236}">
+                  <a16:creationId xmlns:a16="http://schemas.microsoft.com/office/drawing/2014/main" id="{E0A8BE8A-F013-0689-5CE1-E2CC721898D3}"/>
+                </a:ext>
+              </a:extLst>
+            </p:cNvPr>
+            <p:cNvGrpSpPr/>
+            <p:nvPr/>
+          </p:nvGrpSpPr>
+          <p:grpSpPr>
+            <a:xfrm>
+              <a:off x="4575059" y="1910560"/>
+              <a:ext cx="7397752" cy="2536581"/>
+              <a:chOff x="4575059" y="1910560"/>
+              <a:chExt cx="7397752" cy="2536581"/>
+            </a:xfrm>
+          </p:grpSpPr>
+          <p:pic>
+            <p:nvPicPr>
+              <p:cNvPr id="6" name="그림 5">
+                <a:extLst>
+                  <a:ext uri="{FF2B5EF4-FFF2-40B4-BE49-F238E27FC236}">
+                    <a16:creationId xmlns:a16="http://schemas.microsoft.com/office/drawing/2014/main" id="{DF509188-F1F2-0D70-F4D2-0153793728AE}"/>
+                  </a:ext>
+                </a:extLst>
+              </p:cNvPr>
+              <p:cNvPicPr>
+                <a:picLocks noChangeAspect="1"/>
+              </p:cNvPicPr>
+              <p:nvPr/>
+            </p:nvPicPr>
+            <p:blipFill>
+              <a:blip r:embed="rId3"/>
+              <a:stretch>
+                <a:fillRect/>
+              </a:stretch>
+            </p:blipFill>
+            <p:spPr>
+              <a:xfrm>
+                <a:off x="4575059" y="1910560"/>
+                <a:ext cx="7397752" cy="2536581"/>
+              </a:xfrm>
+              <a:prstGeom prst="rect">
+                <a:avLst/>
+              </a:prstGeom>
+            </p:spPr>
+          </p:pic>
+          <p:sp>
+            <p:nvSpPr>
+              <p:cNvPr id="7" name="직사각형 6">
+                <a:extLst>
+                  <a:ext uri="{FF2B5EF4-FFF2-40B4-BE49-F238E27FC236}">
+                    <a16:creationId xmlns:a16="http://schemas.microsoft.com/office/drawing/2014/main" id="{6624BCD9-03C6-15B4-03A6-5771D3F17CB1}"/>
+                  </a:ext>
+                </a:extLst>
+              </p:cNvPr>
+              <p:cNvSpPr/>
+              <p:nvPr/>
+            </p:nvSpPr>
+            <p:spPr>
+              <a:xfrm>
+                <a:off x="7230359" y="3619893"/>
+                <a:ext cx="3148552" cy="254523"/>
+              </a:xfrm>
+              <a:prstGeom prst="rect">
+                <a:avLst/>
+              </a:prstGeom>
+              <a:noFill/>
+              <a:ln>
+                <a:solidFill>
+                  <a:srgbClr val="FF0000"/>
+                </a:solidFill>
+              </a:ln>
+            </p:spPr>
+            <p:style>
+              <a:lnRef idx="2">
+                <a:schemeClr val="accent1">
+                  <a:shade val="15000"/>
+                </a:schemeClr>
+              </a:lnRef>
+              <a:fillRef idx="1">
+                <a:schemeClr val="accent1"/>
+              </a:fillRef>
+              <a:effectRef idx="0">
+                <a:schemeClr val="accent1"/>
+              </a:effectRef>
+              <a:fontRef idx="minor">
+                <a:schemeClr val="lt1"/>
+              </a:fontRef>
+            </p:style>
+            <p:txBody>
+              <a:bodyPr rtlCol="0" anchor="ctr"/>
+              <a:lstStyle/>
+              <a:p>
+                <a:pPr algn="ctr"/>
+                <a:endParaRPr lang="ko-KR" altLang="en-US"/>
+              </a:p>
+            </p:txBody>
+          </p:sp>
+        </p:grpSp>
+        <p:sp>
+          <p:nvSpPr>
+            <p:cNvPr id="11" name="직사각형 10">
+              <a:extLst>
+                <a:ext uri="{FF2B5EF4-FFF2-40B4-BE49-F238E27FC236}">
+                  <a16:creationId xmlns:a16="http://schemas.microsoft.com/office/drawing/2014/main" id="{50AC4D42-8A91-5ECE-9F56-D144CA4A0B2B}"/>
+                </a:ext>
+              </a:extLst>
+            </p:cNvPr>
+            <p:cNvSpPr/>
+            <p:nvPr/>
+          </p:nvSpPr>
+          <p:spPr>
+            <a:xfrm>
+              <a:off x="7627855" y="4192618"/>
+              <a:ext cx="677159" cy="254523"/>
+            </a:xfrm>
+            <a:prstGeom prst="rect">
+              <a:avLst/>
+            </a:prstGeom>
+            <a:noFill/>
+            <a:ln>
+              <a:solidFill>
+                <a:srgbClr val="FF0000"/>
+              </a:solidFill>
+            </a:ln>
+          </p:spPr>
+          <p:style>
+            <a:lnRef idx="2">
+              <a:schemeClr val="accent1">
+                <a:shade val="15000"/>
+              </a:schemeClr>
+            </a:lnRef>
+            <a:fillRef idx="1">
+              <a:schemeClr val="accent1"/>
+            </a:fillRef>
+            <a:effectRef idx="0">
+              <a:schemeClr val="accent1"/>
+            </a:effectRef>
+            <a:fontRef idx="minor">
+              <a:schemeClr val="lt1"/>
+            </a:fontRef>
+          </p:style>
+          <p:txBody>
+            <a:bodyPr rtlCol="0" anchor="ctr"/>
+            <a:lstStyle/>
+            <a:p>
+              <a:pPr algn="ctr"/>
+              <a:endParaRPr lang="ko-KR" altLang="en-US"/>
+            </a:p>
+          </p:txBody>
+        </p:sp>
+      </p:grpSp>
+      <p:grpSp>
+        <p:nvGrpSpPr>
+          <p:cNvPr id="14" name="그룹 13">
+            <a:extLst>
+              <a:ext uri="{FF2B5EF4-FFF2-40B4-BE49-F238E27FC236}">
+                <a16:creationId xmlns:a16="http://schemas.microsoft.com/office/drawing/2014/main" id="{136F670F-A6A0-9E03-2256-8E96125D16D5}"/>
+              </a:ext>
+            </a:extLst>
+          </p:cNvPr>
+          <p:cNvGrpSpPr/>
+          <p:nvPr/>
+        </p:nvGrpSpPr>
+        <p:grpSpPr>
+          <a:xfrm>
+            <a:off x="3886902" y="4620341"/>
+            <a:ext cx="3412587" cy="2039926"/>
+            <a:chOff x="3886902" y="4620341"/>
+            <a:chExt cx="3412587" cy="2039926"/>
+          </a:xfrm>
+        </p:grpSpPr>
+        <p:pic>
+          <p:nvPicPr>
+            <p:cNvPr id="10" name="그림 9">
+              <a:extLst>
+                <a:ext uri="{FF2B5EF4-FFF2-40B4-BE49-F238E27FC236}">
+                  <a16:creationId xmlns:a16="http://schemas.microsoft.com/office/drawing/2014/main" id="{142B6723-4D50-B59F-1C4D-83BF3B07E188}"/>
+                </a:ext>
+              </a:extLst>
+            </p:cNvPr>
+            <p:cNvPicPr>
+              <a:picLocks noChangeAspect="1"/>
+            </p:cNvPicPr>
+            <p:nvPr/>
+          </p:nvPicPr>
+          <p:blipFill>
+            <a:blip r:embed="rId4"/>
+            <a:stretch>
+              <a:fillRect/>
+            </a:stretch>
+          </p:blipFill>
+          <p:spPr>
+            <a:xfrm>
+              <a:off x="3886902" y="4620341"/>
+              <a:ext cx="3412587" cy="2039926"/>
+            </a:xfrm>
+            <a:prstGeom prst="rect">
+              <a:avLst/>
+            </a:prstGeom>
+          </p:spPr>
+        </p:pic>
+        <p:sp>
+          <p:nvSpPr>
+            <p:cNvPr id="13" name="직사각형 12">
+              <a:extLst>
+                <a:ext uri="{FF2B5EF4-FFF2-40B4-BE49-F238E27FC236}">
+                  <a16:creationId xmlns:a16="http://schemas.microsoft.com/office/drawing/2014/main" id="{3FBA325D-E03B-365C-6A71-664344C89EFD}"/>
+                </a:ext>
+              </a:extLst>
+            </p:cNvPr>
+            <p:cNvSpPr/>
+            <p:nvPr/>
+          </p:nvSpPr>
+          <p:spPr>
+            <a:xfrm>
+              <a:off x="3978111" y="5052767"/>
+              <a:ext cx="3252248" cy="386499"/>
+            </a:xfrm>
+            <a:prstGeom prst="rect">
+              <a:avLst/>
+            </a:prstGeom>
+            <a:noFill/>
+            <a:ln>
+              <a:solidFill>
+                <a:srgbClr val="FF0000"/>
+              </a:solidFill>
+            </a:ln>
+          </p:spPr>
+          <p:style>
+            <a:lnRef idx="2">
+              <a:schemeClr val="accent1">
+                <a:shade val="15000"/>
+              </a:schemeClr>
+            </a:lnRef>
+            <a:fillRef idx="1">
+              <a:schemeClr val="accent1"/>
+            </a:fillRef>
+            <a:effectRef idx="0">
+              <a:schemeClr val="accent1"/>
+            </a:effectRef>
+            <a:fontRef idx="minor">
+              <a:schemeClr val="lt1"/>
+            </a:fontRef>
+          </p:style>
+          <p:txBody>
+            <a:bodyPr rtlCol="0" anchor="ctr"/>
+            <a:lstStyle/>
+            <a:p>
+              <a:pPr algn="ctr"/>
+              <a:endParaRPr lang="ko-KR" altLang="en-US"/>
+            </a:p>
+          </p:txBody>
+        </p:sp>
+      </p:grpSp>
+    </p:spTree>
+    <p:extLst>
+      <p:ext uri="{BB962C8B-B14F-4D97-AF65-F5344CB8AC3E}">
+        <p14:creationId xmlns:p14="http://schemas.microsoft.com/office/powerpoint/2010/main" val="1528240695"/>
+      </p:ext>
+    </p:extLst>
+  </p:cSld>
+  <p:clrMapOvr>
+    <a:masterClrMapping/>
+  </p:clrMapOvr>
+</p:sld>
+</file>
+
+<file path=ppt/slides/slide7.xml><?xml version="1.0" encoding="utf-8"?>
+<p:sld xmlns:a="http://schemas.openxmlformats.org/drawingml/2006/main" xmlns:r="http://schemas.openxmlformats.org/officeDocument/2006/relationships" xmlns:p="http://schemas.openxmlformats.org/presentationml/2006/main">
+  <p:cSld>
+    <p:spTree>
+      <p:nvGrpSpPr>
+        <p:cNvPr id="1" name=""/>
+        <p:cNvGrpSpPr/>
+        <p:nvPr/>
+      </p:nvGrpSpPr>
+      <p:grpSpPr>
+        <a:xfrm>
+          <a:off x="0" y="0"/>
+          <a:ext cx="0" cy="0"/>
+          <a:chOff x="0" y="0"/>
+          <a:chExt cx="0" cy="0"/>
+        </a:xfrm>
+      </p:grpSpPr>
+      <p:sp>
+        <p:nvSpPr>
+          <p:cNvPr id="2" name="제목 1">
+            <a:extLst>
+              <a:ext uri="{FF2B5EF4-FFF2-40B4-BE49-F238E27FC236}">
+                <a16:creationId xmlns:a16="http://schemas.microsoft.com/office/drawing/2014/main" id="{817C0D89-2FFD-5312-E734-DFA3B6FF301E}"/>
+              </a:ext>
+            </a:extLst>
+          </p:cNvPr>
+          <p:cNvSpPr>
+            <a:spLocks noGrp="1"/>
+          </p:cNvSpPr>
+          <p:nvPr>
+            <p:ph type="title"/>
+          </p:nvPr>
+        </p:nvSpPr>
+        <p:spPr/>
+        <p:txBody>
+          <a:bodyPr/>
+          <a:lstStyle/>
+          <a:p>
+            <a:r>
+              <a:rPr lang="en-US" altLang="ko-KR"/>
+              <a:t>MCP</a:t>
+            </a:r>
+            <a:r>
+              <a:rPr lang="ko-KR" altLang="en-US"/>
+              <a:t> </a:t>
+            </a:r>
+            <a:r>
+              <a:rPr lang="en-US" altLang="ko-KR"/>
+              <a:t>– Install (3) [CLI </a:t>
+            </a:r>
+            <a:r>
+              <a:rPr lang="ko-KR" altLang="en-US"/>
+              <a:t>설치 진행</a:t>
+            </a:r>
+            <a:r>
+              <a:rPr lang="en-US" altLang="ko-KR"/>
+              <a:t>]</a:t>
+            </a:r>
+            <a:endParaRPr lang="ko-KR" altLang="en-US"/>
+          </a:p>
+        </p:txBody>
+      </p:sp>
+      <p:pic>
+        <p:nvPicPr>
+          <p:cNvPr id="4" name="그림 3">
+            <a:extLst>
+              <a:ext uri="{FF2B5EF4-FFF2-40B4-BE49-F238E27FC236}">
+                <a16:creationId xmlns:a16="http://schemas.microsoft.com/office/drawing/2014/main" id="{824522E3-3B69-4581-1904-17F5A487D0F2}"/>
+              </a:ext>
+            </a:extLst>
+          </p:cNvPr>
+          <p:cNvPicPr>
+            <a:picLocks noChangeAspect="1"/>
+          </p:cNvPicPr>
+          <p:nvPr/>
+        </p:nvPicPr>
+        <p:blipFill>
+          <a:blip r:embed="rId2"/>
+          <a:stretch>
+            <a:fillRect/>
+          </a:stretch>
+        </p:blipFill>
+        <p:spPr>
+          <a:xfrm>
+            <a:off x="1097280" y="1843392"/>
+            <a:ext cx="9545382" cy="1267002"/>
+          </a:xfrm>
+          <a:prstGeom prst="rect">
+            <a:avLst/>
+          </a:prstGeom>
+        </p:spPr>
+      </p:pic>
+      <p:sp>
+        <p:nvSpPr>
+          <p:cNvPr id="5" name="TextBox 4">
+            <a:extLst>
+              <a:ext uri="{FF2B5EF4-FFF2-40B4-BE49-F238E27FC236}">
+                <a16:creationId xmlns:a16="http://schemas.microsoft.com/office/drawing/2014/main" id="{71CCF4AF-FA49-F6E5-761F-FA8FD9AFDBCF}"/>
+              </a:ext>
+            </a:extLst>
+          </p:cNvPr>
+          <p:cNvSpPr txBox="1"/>
+          <p:nvPr/>
+        </p:nvSpPr>
+        <p:spPr>
+          <a:xfrm>
+            <a:off x="1097280" y="3195687"/>
+            <a:ext cx="9545382" cy="369332"/>
+          </a:xfrm>
+          <a:prstGeom prst="rect">
+            <a:avLst/>
+          </a:prstGeom>
+          <a:noFill/>
+        </p:spPr>
+        <p:txBody>
+          <a:bodyPr wrap="square" rtlCol="0">
+            <a:spAutoFit/>
+          </a:bodyPr>
+          <a:lstStyle/>
+          <a:p>
+            <a:r>
+              <a:rPr lang="en-US" altLang="ko-KR"/>
+              <a:t>Task Manager </a:t>
+            </a:r>
+            <a:r>
+              <a:rPr lang="ko-KR" altLang="en-US"/>
+              <a:t>프로젝트 초기화 명령</a:t>
+            </a:r>
+          </a:p>
+        </p:txBody>
+      </p:sp>
+      <p:pic>
+        <p:nvPicPr>
+          <p:cNvPr id="7" name="그림 6">
+            <a:extLst>
+              <a:ext uri="{FF2B5EF4-FFF2-40B4-BE49-F238E27FC236}">
+                <a16:creationId xmlns:a16="http://schemas.microsoft.com/office/drawing/2014/main" id="{A5B176BD-34F3-814F-6C30-3140F8A9B217}"/>
+              </a:ext>
+            </a:extLst>
+          </p:cNvPr>
+          <p:cNvPicPr>
+            <a:picLocks noChangeAspect="1"/>
+          </p:cNvPicPr>
+          <p:nvPr/>
+        </p:nvPicPr>
+        <p:blipFill>
+          <a:blip r:embed="rId3"/>
+          <a:stretch>
+            <a:fillRect/>
+          </a:stretch>
+        </p:blipFill>
+        <p:spPr>
+          <a:xfrm>
+            <a:off x="1097280" y="3650312"/>
+            <a:ext cx="9392961" cy="733527"/>
+          </a:xfrm>
+          <a:prstGeom prst="rect">
+            <a:avLst/>
+          </a:prstGeom>
+        </p:spPr>
+      </p:pic>
+      <p:sp>
+        <p:nvSpPr>
+          <p:cNvPr id="8" name="TextBox 7">
+            <a:extLst>
+              <a:ext uri="{FF2B5EF4-FFF2-40B4-BE49-F238E27FC236}">
+                <a16:creationId xmlns:a16="http://schemas.microsoft.com/office/drawing/2014/main" id="{24573099-3734-1E06-0E03-D0D0B273A65B}"/>
+              </a:ext>
+            </a:extLst>
+          </p:cNvPr>
+          <p:cNvSpPr txBox="1"/>
+          <p:nvPr/>
+        </p:nvSpPr>
+        <p:spPr>
+          <a:xfrm>
+            <a:off x="1097280" y="4383839"/>
+            <a:ext cx="9997440" cy="523220"/>
+          </a:xfrm>
+          <a:prstGeom prst="rect">
+            <a:avLst/>
+          </a:prstGeom>
+          <a:noFill/>
+        </p:spPr>
+        <p:txBody>
+          <a:bodyPr wrap="square" rtlCol="0">
+            <a:spAutoFit/>
+          </a:bodyPr>
+          <a:lstStyle/>
+          <a:p>
+            <a:r>
+              <a:rPr lang="en-US" altLang="ko-KR" sz="1400"/>
+              <a:t>Claude Code (CLI) </a:t>
+            </a:r>
+            <a:r>
+              <a:rPr lang="ko-KR" altLang="en-US" sz="1400"/>
+              <a:t>를 통해 </a:t>
+            </a:r>
+            <a:r>
+              <a:rPr lang="en-US" altLang="ko-KR" sz="1400" err="1"/>
+              <a:t>mcp</a:t>
+            </a:r>
+            <a:r>
+              <a:rPr lang="ko-KR" altLang="en-US" sz="1400"/>
+              <a:t>를 사용할 경우 </a:t>
+            </a:r>
+            <a:r>
+              <a:rPr lang="en-US" altLang="ko-KR" sz="1400"/>
+              <a:t>Research </a:t>
+            </a:r>
+            <a:r>
+              <a:rPr lang="ko-KR" altLang="en-US" sz="1400"/>
+              <a:t>명령은 별도의 </a:t>
+            </a:r>
+            <a:r>
+              <a:rPr lang="en-US" altLang="ko-KR" sz="1400"/>
+              <a:t>API </a:t>
+            </a:r>
+            <a:r>
+              <a:rPr lang="ko-KR" altLang="en-US" sz="1400"/>
+              <a:t>키가 필요하다 한다</a:t>
+            </a:r>
+            <a:r>
+              <a:rPr lang="en-US" altLang="ko-KR" sz="1400"/>
+              <a:t>. </a:t>
+            </a:r>
+          </a:p>
+          <a:p>
+            <a:r>
+              <a:rPr lang="en-US" altLang="ko-KR" sz="1400">
+                <a:sym typeface="Wingdings" panose="05000000000000000000" pitchFamily="2" charset="2"/>
+              </a:rPr>
+              <a:t> </a:t>
+            </a:r>
+            <a:r>
+              <a:rPr lang="ko-KR" altLang="en-US" sz="1400">
+                <a:sym typeface="Wingdings" panose="05000000000000000000" pitchFamily="2" charset="2"/>
+              </a:rPr>
+              <a:t>유료</a:t>
+            </a:r>
+            <a:r>
+              <a:rPr lang="en-US" altLang="ko-KR" sz="1400">
+                <a:sym typeface="Wingdings" panose="05000000000000000000" pitchFamily="2" charset="2"/>
+              </a:rPr>
+              <a:t>(</a:t>
+            </a:r>
+            <a:r>
+              <a:rPr lang="ko-KR" altLang="en-US" sz="1400">
+                <a:sym typeface="Wingdings" panose="05000000000000000000" pitchFamily="2" charset="2"/>
+              </a:rPr>
+              <a:t>정액제와 다른 토큰 사용량 결제</a:t>
+            </a:r>
+            <a:r>
+              <a:rPr lang="en-US" altLang="ko-KR" sz="1400">
+                <a:sym typeface="Wingdings" panose="05000000000000000000" pitchFamily="2" charset="2"/>
+              </a:rPr>
+              <a:t>)</a:t>
+            </a:r>
+            <a:endParaRPr lang="ko-KR" altLang="en-US" sz="1400"/>
+          </a:p>
+        </p:txBody>
+      </p:sp>
+    </p:spTree>
+    <p:extLst>
+      <p:ext uri="{BB962C8B-B14F-4D97-AF65-F5344CB8AC3E}">
+        <p14:creationId xmlns:p14="http://schemas.microsoft.com/office/powerpoint/2010/main" val="1580267021"/>
+      </p:ext>
+    </p:extLst>
+  </p:cSld>
+  <p:clrMapOvr>
+    <a:masterClrMapping/>
+  </p:clrMapOvr>
+</p:sld>
+</file>
+
+<file path=ppt/slides/slide8.xml><?xml version="1.0" encoding="utf-8"?>
+<p:sld xmlns:a="http://schemas.openxmlformats.org/drawingml/2006/main" xmlns:r="http://schemas.openxmlformats.org/officeDocument/2006/relationships" xmlns:p="http://schemas.openxmlformats.org/presentationml/2006/main">
+  <p:cSld>
+    <p:spTree>
+      <p:nvGrpSpPr>
+        <p:cNvPr id="1" name=""/>
+        <p:cNvGrpSpPr/>
+        <p:nvPr/>
+      </p:nvGrpSpPr>
+      <p:grpSpPr>
+        <a:xfrm>
+          <a:off x="0" y="0"/>
+          <a:ext cx="0" cy="0"/>
+          <a:chOff x="0" y="0"/>
+          <a:chExt cx="0" cy="0"/>
+        </a:xfrm>
+      </p:grpSpPr>
+      <p:sp>
+        <p:nvSpPr>
+          <p:cNvPr id="2" name="제목 1">
+            <a:extLst>
+              <a:ext uri="{FF2B5EF4-FFF2-40B4-BE49-F238E27FC236}">
+                <a16:creationId xmlns:a16="http://schemas.microsoft.com/office/drawing/2014/main" id="{A1313251-DB29-B843-50B9-FDA207345460}"/>
+              </a:ext>
+            </a:extLst>
+          </p:cNvPr>
+          <p:cNvSpPr>
+            <a:spLocks noGrp="1"/>
+          </p:cNvSpPr>
+          <p:nvPr>
+            <p:ph type="title"/>
+          </p:nvPr>
+        </p:nvSpPr>
+        <p:spPr/>
+        <p:txBody>
+          <a:bodyPr>
+            <a:normAutofit/>
+          </a:bodyPr>
+          <a:lstStyle/>
+          <a:p>
+            <a:r>
+              <a:rPr lang="en-US" altLang="ko-KR" sz="2800"/>
+              <a:t>API </a:t>
+            </a:r>
+            <a:r>
+              <a:rPr lang="ko-KR" altLang="en-US" sz="2800"/>
+              <a:t>키를 활성화 하고 </a:t>
+            </a:r>
+            <a:r>
+              <a:rPr lang="ko-KR" altLang="en-US" sz="2800" err="1"/>
+              <a:t>싶은경우</a:t>
+            </a:r>
+            <a:r>
+              <a:rPr lang="en-US" altLang="ko-KR" sz="2800"/>
+              <a:t>. (</a:t>
+            </a:r>
+            <a:r>
+              <a:rPr lang="ko-KR" altLang="en-US" sz="2800"/>
+              <a:t>사용량에 따라 유료 금액</a:t>
+            </a:r>
+            <a:r>
+              <a:rPr lang="en-US" altLang="ko-KR" sz="2800"/>
+              <a:t>)</a:t>
+            </a:r>
+            <a:endParaRPr lang="ko-KR" altLang="en-US" sz="2800"/>
+          </a:p>
+        </p:txBody>
+      </p:sp>
+      <p:pic>
+        <p:nvPicPr>
+          <p:cNvPr id="4" name="그림 3">
+            <a:extLst>
+              <a:ext uri="{FF2B5EF4-FFF2-40B4-BE49-F238E27FC236}">
+                <a16:creationId xmlns:a16="http://schemas.microsoft.com/office/drawing/2014/main" id="{14609E66-6BCF-313F-2A37-4636FB5AA7EF}"/>
+              </a:ext>
+            </a:extLst>
+          </p:cNvPr>
+          <p:cNvPicPr>
+            <a:picLocks noChangeAspect="1"/>
+          </p:cNvPicPr>
+          <p:nvPr/>
+        </p:nvPicPr>
+        <p:blipFill>
+          <a:blip r:embed="rId2"/>
+          <a:stretch>
+            <a:fillRect/>
+          </a:stretch>
+        </p:blipFill>
+        <p:spPr>
+          <a:xfrm>
+            <a:off x="801755" y="1847653"/>
+            <a:ext cx="10588490" cy="3591723"/>
+          </a:xfrm>
+          <a:prstGeom prst="rect">
+            <a:avLst/>
+          </a:prstGeom>
+          <a:ln>
+            <a:solidFill>
+              <a:schemeClr val="tx1"/>
+            </a:solidFill>
+          </a:ln>
+        </p:spPr>
+      </p:pic>
+      <p:sp>
+        <p:nvSpPr>
+          <p:cNvPr id="6" name="TextBox 5">
+            <a:extLst>
+              <a:ext uri="{FF2B5EF4-FFF2-40B4-BE49-F238E27FC236}">
+                <a16:creationId xmlns:a16="http://schemas.microsoft.com/office/drawing/2014/main" id="{B9E35639-F973-515E-28BD-20D0A71D3831}"/>
+              </a:ext>
+            </a:extLst>
+          </p:cNvPr>
+          <p:cNvSpPr txBox="1"/>
+          <p:nvPr/>
+        </p:nvSpPr>
+        <p:spPr>
+          <a:xfrm>
+            <a:off x="728221" y="5439376"/>
+            <a:ext cx="6094428" cy="1015663"/>
+          </a:xfrm>
+          <a:prstGeom prst="rect">
+            <a:avLst/>
+          </a:prstGeom>
+          <a:noFill/>
+        </p:spPr>
+        <p:txBody>
+          <a:bodyPr wrap="square">
+            <a:spAutoFit/>
+          </a:bodyPr>
+          <a:lstStyle/>
+          <a:p>
+            <a:r>
+              <a:rPr lang="en-US" altLang="ko-KR" sz="1200"/>
+              <a:t>Anthropic</a:t>
+            </a:r>
+            <a:r>
+              <a:rPr lang="ko-KR" altLang="en-US" sz="1200"/>
+              <a:t> 로그인 </a:t>
+            </a:r>
+            <a:r>
+              <a:rPr lang="en-US" altLang="ko-KR" sz="1200"/>
+              <a:t>-&gt; </a:t>
+            </a:r>
+            <a:r>
+              <a:rPr lang="ko-KR" altLang="en-US" sz="1200">
+                <a:hlinkClick r:id="rId3"/>
+              </a:rPr>
+              <a:t>https://platform.claude.com/settings/keys</a:t>
+            </a:r>
+            <a:endParaRPr lang="en-US" altLang="ko-KR" sz="1200"/>
+          </a:p>
+          <a:p>
+            <a:r>
+              <a:rPr lang="en-US" altLang="ko-KR" sz="1200"/>
+              <a:t>- </a:t>
+            </a:r>
+            <a:r>
+              <a:rPr lang="en-US" altLang="ko-KR" sz="1200" err="1"/>
+              <a:t>Mcp.json</a:t>
+            </a:r>
+            <a:r>
+              <a:rPr lang="en-US" altLang="ko-KR" sz="1200"/>
+              <a:t> [※ API </a:t>
+            </a:r>
+            <a:r>
+              <a:rPr lang="ko-KR" altLang="en-US" sz="1200"/>
+              <a:t>키는 노출되면 안됨으로 </a:t>
+            </a:r>
+            <a:r>
+              <a:rPr lang="en-US" altLang="ko-KR" sz="1200"/>
+              <a:t>.env </a:t>
+            </a:r>
+            <a:r>
+              <a:rPr lang="ko-KR" altLang="en-US" sz="1200"/>
+              <a:t>파일로 </a:t>
+            </a:r>
+            <a:r>
+              <a:rPr lang="ko-KR" altLang="en-US" sz="1200" err="1"/>
+              <a:t>저장하는게</a:t>
+            </a:r>
+            <a:r>
+              <a:rPr lang="ko-KR" altLang="en-US" sz="1200"/>
+              <a:t> 일반적</a:t>
+            </a:r>
+            <a:r>
+              <a:rPr lang="en-US" altLang="ko-KR" sz="1200"/>
+              <a:t>]</a:t>
+            </a:r>
+          </a:p>
+          <a:p>
+            <a:r>
+              <a:rPr lang="ko-KR" altLang="en-US" sz="1200"/>
+              <a:t> </a:t>
+            </a:r>
+            <a:r>
+              <a:rPr lang="en-US" altLang="ko-KR" sz="1200"/>
+              <a:t>env : {</a:t>
+            </a:r>
+          </a:p>
+          <a:p>
+            <a:r>
+              <a:rPr lang="en-US" altLang="ko-KR" sz="1200"/>
+              <a:t>	</a:t>
+            </a:r>
+            <a:r>
+              <a:rPr lang="ko-KR" altLang="en-US" sz="1200"/>
+              <a:t>"ANTHROPIC_API_KEY": "YOUR_ANTHROPIC_API_KEY_HERE“</a:t>
+            </a:r>
+            <a:br>
+              <a:rPr lang="en-US" altLang="ko-KR" sz="1200"/>
+            </a:br>
+            <a:r>
+              <a:rPr lang="en-US" altLang="ko-KR" sz="1200"/>
+              <a:t>}</a:t>
+            </a:r>
+            <a:r>
+              <a:rPr lang="ko-KR" altLang="en-US" sz="1200"/>
+              <a:t> </a:t>
+            </a:r>
+          </a:p>
+        </p:txBody>
+      </p:sp>
+    </p:spTree>
+    <p:extLst>
+      <p:ext uri="{BB962C8B-B14F-4D97-AF65-F5344CB8AC3E}">
+        <p14:creationId xmlns:p14="http://schemas.microsoft.com/office/powerpoint/2010/main" val="1056510942"/>
+      </p:ext>
+    </p:extLst>
+  </p:cSld>
+  <p:clrMapOvr>
+    <a:masterClrMapping/>
+  </p:clrMapOvr>
+</p:sld>
+</file>
+
+<file path=ppt/slides/slide9.xml><?xml version="1.0" encoding="utf-8"?>
+<p:sld xmlns:a="http://schemas.openxmlformats.org/drawingml/2006/main" xmlns:r="http://schemas.openxmlformats.org/officeDocument/2006/relationships" xmlns:p="http://schemas.openxmlformats.org/presentationml/2006/main">
+  <p:cSld>
+    <p:spTree>
+      <p:nvGrpSpPr>
+        <p:cNvPr id="1" name=""/>
+        <p:cNvGrpSpPr/>
+        <p:nvPr/>
+      </p:nvGrpSpPr>
+      <p:grpSpPr>
+        <a:xfrm>
+          <a:off x="0" y="0"/>
+          <a:ext cx="0" cy="0"/>
+          <a:chOff x="0" y="0"/>
+          <a:chExt cx="0" cy="0"/>
+        </a:xfrm>
+      </p:grpSpPr>
+      <p:sp>
+        <p:nvSpPr>
+          <p:cNvPr id="2" name="제목 1">
+            <a:extLst>
+              <a:ext uri="{FF2B5EF4-FFF2-40B4-BE49-F238E27FC236}">
+                <a16:creationId xmlns:a16="http://schemas.microsoft.com/office/drawing/2014/main" id="{E2CC9EE9-2771-3735-60AE-D38887F6CA13}"/>
+              </a:ext>
+            </a:extLst>
+          </p:cNvPr>
+          <p:cNvSpPr>
+            <a:spLocks noGrp="1"/>
+          </p:cNvSpPr>
+          <p:nvPr>
+            <p:ph type="title"/>
+          </p:nvPr>
+        </p:nvSpPr>
+        <p:spPr/>
+        <p:txBody>
+          <a:bodyPr/>
+          <a:lstStyle/>
+          <a:p>
+            <a:r>
+              <a:rPr lang="en-US" altLang="ko-KR"/>
+              <a:t>Task Manager </a:t>
+            </a:r>
+            <a:r>
+              <a:rPr lang="ko-KR" altLang="en-US"/>
+              <a:t>사용가능 모델 확인</a:t>
+            </a:r>
+          </a:p>
+        </p:txBody>
+      </p:sp>
+      <p:pic>
+        <p:nvPicPr>
+          <p:cNvPr id="4" name="그림 3">
+            <a:extLst>
+              <a:ext uri="{FF2B5EF4-FFF2-40B4-BE49-F238E27FC236}">
+                <a16:creationId xmlns:a16="http://schemas.microsoft.com/office/drawing/2014/main" id="{CD41D321-B684-1151-DA2A-F78D31F4589B}"/>
+              </a:ext>
+            </a:extLst>
+          </p:cNvPr>
+          <p:cNvPicPr>
+            <a:picLocks noChangeAspect="1"/>
+          </p:cNvPicPr>
+          <p:nvPr/>
+        </p:nvPicPr>
+        <p:blipFill>
+          <a:blip r:embed="rId2"/>
+          <a:stretch>
+            <a:fillRect/>
+          </a:stretch>
+        </p:blipFill>
+        <p:spPr>
+          <a:xfrm>
+            <a:off x="391163" y="1933053"/>
+            <a:ext cx="2114845" cy="3953427"/>
+          </a:xfrm>
+          <a:prstGeom prst="rect">
+            <a:avLst/>
+          </a:prstGeom>
+        </p:spPr>
+      </p:pic>
+      <p:pic>
+        <p:nvPicPr>
+          <p:cNvPr id="6" name="그림 5">
+            <a:extLst>
+              <a:ext uri="{FF2B5EF4-FFF2-40B4-BE49-F238E27FC236}">
+                <a16:creationId xmlns:a16="http://schemas.microsoft.com/office/drawing/2014/main" id="{0FCDF12C-B1F6-DF5A-A62D-B9DA085D9422}"/>
+              </a:ext>
+            </a:extLst>
+          </p:cNvPr>
+          <p:cNvPicPr>
+            <a:picLocks noChangeAspect="1"/>
+          </p:cNvPicPr>
+          <p:nvPr/>
+        </p:nvPicPr>
+        <p:blipFill>
+          <a:blip r:embed="rId3"/>
+          <a:stretch>
+            <a:fillRect/>
+          </a:stretch>
+        </p:blipFill>
+        <p:spPr>
+          <a:xfrm>
+            <a:off x="2595230" y="1933053"/>
+            <a:ext cx="2584799" cy="4840092"/>
+          </a:xfrm>
+          <a:prstGeom prst="rect">
+            <a:avLst/>
+          </a:prstGeom>
+        </p:spPr>
+      </p:pic>
+      <p:sp>
+        <p:nvSpPr>
+          <p:cNvPr id="7" name="TextBox 6">
+            <a:extLst>
+              <a:ext uri="{FF2B5EF4-FFF2-40B4-BE49-F238E27FC236}">
+                <a16:creationId xmlns:a16="http://schemas.microsoft.com/office/drawing/2014/main" id="{F2E3FE81-D3AB-97C8-9333-E8AE03870950}"/>
+              </a:ext>
+            </a:extLst>
+          </p:cNvPr>
+          <p:cNvSpPr txBox="1"/>
+          <p:nvPr/>
+        </p:nvSpPr>
+        <p:spPr>
+          <a:xfrm>
+            <a:off x="5269251" y="1933053"/>
+            <a:ext cx="2394409" cy="430887"/>
+          </a:xfrm>
+          <a:prstGeom prst="rect">
+            <a:avLst/>
+          </a:prstGeom>
+          <a:noFill/>
+        </p:spPr>
+        <p:txBody>
+          <a:bodyPr wrap="square" rtlCol="0">
+            <a:spAutoFit/>
+          </a:bodyPr>
+          <a:lstStyle/>
+          <a:p>
+            <a:r>
+              <a:rPr lang="ko-KR" altLang="en-US" sz="1100"/>
+              <a:t>지원하는 모델을 </a:t>
+            </a:r>
+            <a:r>
+              <a:rPr lang="en-US" altLang="ko-KR" sz="1100"/>
+              <a:t>.taskmaster</a:t>
+            </a:r>
+            <a:r>
+              <a:rPr lang="ko-KR" altLang="en-US" sz="1100"/>
+              <a:t>내 </a:t>
+            </a:r>
+            <a:r>
+              <a:rPr lang="en-US" altLang="ko-KR" sz="1100" err="1"/>
+              <a:t>config.json</a:t>
+            </a:r>
+            <a:r>
+              <a:rPr lang="ko-KR" altLang="en-US" sz="1100"/>
+              <a:t>으로 확인할 수 있다</a:t>
+            </a:r>
+            <a:r>
+              <a:rPr lang="en-US" altLang="ko-KR" sz="1100"/>
+              <a:t>.</a:t>
+            </a:r>
+            <a:endParaRPr lang="ko-KR" altLang="en-US" sz="1100"/>
+          </a:p>
+        </p:txBody>
+      </p:sp>
+    </p:spTree>
+    <p:extLst>
+      <p:ext uri="{BB962C8B-B14F-4D97-AF65-F5344CB8AC3E}">
+        <p14:creationId xmlns:p14="http://schemas.microsoft.com/office/powerpoint/2010/main" val="1330884146"/>
       </p:ext>
     </p:extLst>
   </p:cSld>

</xml_diff>